<commit_message>
Add Endpoints ativar-desativar-login-logout (realizarAjustes)
</commit_message>
<xml_diff>
--- a/Docs/ENTREGA_1.pptx
+++ b/Docs/ENTREGA_1.pptx
@@ -5,30 +5,27 @@
     <p:sldMasterId id="2147483659" r:id="rId1"/>
   </p:sldMasterIdLst>
   <p:notesMasterIdLst>
-    <p:notesMasterId r:id="rId8"/>
+    <p:notesMasterId r:id="rId5"/>
   </p:notesMasterIdLst>
   <p:sldIdLst>
     <p:sldId id="256" r:id="rId2"/>
-    <p:sldId id="257" r:id="rId3"/>
-    <p:sldId id="274" r:id="rId4"/>
-    <p:sldId id="278" r:id="rId5"/>
-    <p:sldId id="275" r:id="rId6"/>
-    <p:sldId id="279" r:id="rId7"/>
+    <p:sldId id="276" r:id="rId3"/>
+    <p:sldId id="280" r:id="rId4"/>
   </p:sldIdLst>
   <p:sldSz cx="18288000" cy="10287000"/>
   <p:notesSz cx="6858000" cy="9144000"/>
   <p:embeddedFontLst>
     <p:embeddedFont>
       <p:font typeface="Blinker" panose="020B0604020202020204" charset="0"/>
-      <p:bold r:id="rId9"/>
+      <p:bold r:id="rId6"/>
     </p:embeddedFont>
     <p:embeddedFont>
       <p:font typeface="League Spartan" panose="020B0604020202020204" charset="0"/>
-      <p:bold r:id="rId10"/>
+      <p:bold r:id="rId7"/>
     </p:embeddedFont>
     <p:embeddedFont>
       <p:font typeface="League Spartan ExtraBold" panose="020B0604020202020204" charset="0"/>
-      <p:bold r:id="rId11"/>
+      <p:bold r:id="rId8"/>
     </p:embeddedFont>
   </p:embeddedFontLst>
   <p:defaultTextStyle>
@@ -829,7 +826,7 @@
   <p:cSld>
     <p:spTree>
       <p:nvGrpSpPr>
-        <p:cNvPr id="1" name="Shape 90"/>
+        <p:cNvPr id="1" name="Shape 537"/>
         <p:cNvGrpSpPr/>
         <p:nvPr/>
       </p:nvGrpSpPr>
@@ -843,7 +840,7 @@
       </p:grpSpPr>
       <p:sp>
         <p:nvSpPr>
-          <p:cNvPr id="91" name="Google Shape;91;p3:notes"/>
+          <p:cNvPr id="538" name="Google Shape;538;p19:notes"/>
           <p:cNvSpPr txBox="1">
             <a:spLocks noGrp="1"/>
           </p:cNvSpPr>
@@ -881,111 +878,7 @@
       </p:sp>
       <p:sp>
         <p:nvSpPr>
-          <p:cNvPr id="92" name="Google Shape;92;p3:notes"/>
-          <p:cNvSpPr>
-            <a:spLocks noGrp="1" noRot="1" noChangeAspect="1"/>
-          </p:cNvSpPr>
-          <p:nvPr>
-            <p:ph type="sldImg" idx="2"/>
-          </p:nvPr>
-        </p:nvSpPr>
-        <p:spPr>
-          <a:xfrm>
-            <a:off x="381000" y="685800"/>
-            <a:ext cx="6096000" cy="3429000"/>
-          </a:xfrm>
-          <a:custGeom>
-            <a:avLst/>
-            <a:gdLst/>
-            <a:ahLst/>
-            <a:cxnLst/>
-            <a:rect l="l" t="t" r="r" b="b"/>
-            <a:pathLst>
-              <a:path w="120000" h="120000" extrusionOk="0">
-                <a:moveTo>
-                  <a:pt x="0" y="0"/>
-                </a:moveTo>
-                <a:lnTo>
-                  <a:pt x="120000" y="0"/>
-                </a:lnTo>
-                <a:lnTo>
-                  <a:pt x="120000" y="120000"/>
-                </a:lnTo>
-                <a:lnTo>
-                  <a:pt x="0" y="120000"/>
-                </a:lnTo>
-                <a:close/>
-              </a:path>
-            </a:pathLst>
-          </a:custGeom>
-        </p:spPr>
-      </p:sp>
-    </p:spTree>
-  </p:cSld>
-  <p:clrMapOvr>
-    <a:masterClrMapping/>
-  </p:clrMapOvr>
-</p:notes>
-</file>
-
-<file path=ppt/notesSlides/notesSlide3.xml><?xml version="1.0" encoding="utf-8"?>
-<p:notes xmlns:a="http://schemas.openxmlformats.org/drawingml/2006/main" xmlns:r="http://schemas.openxmlformats.org/officeDocument/2006/relationships" xmlns:p="http://schemas.openxmlformats.org/presentationml/2006/main" showMasterSp="0" showMasterPhAnim="0">
-  <p:cSld>
-    <p:spTree>
-      <p:nvGrpSpPr>
-        <p:cNvPr id="1" name="Shape 90"/>
-        <p:cNvGrpSpPr/>
-        <p:nvPr/>
-      </p:nvGrpSpPr>
-      <p:grpSpPr>
-        <a:xfrm>
-          <a:off x="0" y="0"/>
-          <a:ext cx="0" cy="0"/>
-          <a:chOff x="0" y="0"/>
-          <a:chExt cx="0" cy="0"/>
-        </a:xfrm>
-      </p:grpSpPr>
-      <p:sp>
-        <p:nvSpPr>
-          <p:cNvPr id="91" name="Google Shape;91;p3:notes"/>
-          <p:cNvSpPr txBox="1">
-            <a:spLocks noGrp="1"/>
-          </p:cNvSpPr>
-          <p:nvPr>
-            <p:ph type="body" idx="1"/>
-          </p:nvPr>
-        </p:nvSpPr>
-        <p:spPr>
-          <a:xfrm>
-            <a:off x="685800" y="4343400"/>
-            <a:ext cx="5486400" cy="4114800"/>
-          </a:xfrm>
-          <a:prstGeom prst="rect">
-            <a:avLst/>
-          </a:prstGeom>
-        </p:spPr>
-        <p:txBody>
-          <a:bodyPr spcFirstLastPara="1" wrap="square" lIns="91425" tIns="91425" rIns="91425" bIns="91425" anchor="t" anchorCtr="0">
-            <a:noAutofit/>
-          </a:bodyPr>
-          <a:lstStyle/>
-          <a:p>
-            <a:pPr marL="0" lvl="0" indent="0" algn="l" rtl="0">
-              <a:spcBef>
-                <a:spcPts val="0"/>
-              </a:spcBef>
-              <a:spcAft>
-                <a:spcPts val="0"/>
-              </a:spcAft>
-              <a:buNone/>
-            </a:pPr>
-            <a:endParaRPr/>
-          </a:p>
-        </p:txBody>
-      </p:sp>
-      <p:sp>
-        <p:nvSpPr>
-          <p:cNvPr id="92" name="Google Shape;92;p3:notes"/>
+          <p:cNvPr id="539" name="Google Shape;539;p19:notes"/>
           <p:cNvSpPr>
             <a:spLocks noGrp="1" noRot="1" noChangeAspect="1"/>
           </p:cNvSpPr>
@@ -1027,7 +920,7 @@
     </p:spTree>
     <p:extLst>
       <p:ext uri="{BB962C8B-B14F-4D97-AF65-F5344CB8AC3E}">
-        <p14:creationId xmlns:p14="http://schemas.microsoft.com/office/powerpoint/2010/main" val="2432068330"/>
+        <p14:creationId xmlns:p14="http://schemas.microsoft.com/office/powerpoint/2010/main" val="1439220814"/>
       </p:ext>
     </p:extLst>
   </p:cSld>
@@ -1037,15 +930,15 @@
 </p:notes>
 </file>
 
-<file path=ppt/notesSlides/notesSlide4.xml><?xml version="1.0" encoding="utf-8"?>
+<file path=ppt/notesSlides/notesSlide3.xml><?xml version="1.0" encoding="utf-8"?>
 <p:notes xmlns:a="http://schemas.openxmlformats.org/drawingml/2006/main" xmlns:r="http://schemas.openxmlformats.org/officeDocument/2006/relationships" xmlns:p="http://schemas.openxmlformats.org/presentationml/2006/main" showMasterSp="0" showMasterPhAnim="0">
   <p:cSld>
     <p:spTree>
       <p:nvGrpSpPr>
-        <p:cNvPr id="1" name="Shape 90">
+        <p:cNvPr id="1" name="Shape 472">
           <a:extLst>
             <a:ext uri="{FF2B5EF4-FFF2-40B4-BE49-F238E27FC236}">
-              <a16:creationId xmlns:a16="http://schemas.microsoft.com/office/drawing/2014/main" id="{259C33F4-56ED-A6A4-E328-6A7DDF5B0653}"/>
+              <a16:creationId xmlns:a16="http://schemas.microsoft.com/office/drawing/2014/main" id="{D7E839B0-1C95-51C4-9CEA-5977779EED3F}"/>
             </a:ext>
           </a:extLst>
         </p:cNvPr>
@@ -1062,10 +955,10 @@
       </p:grpSpPr>
       <p:sp>
         <p:nvSpPr>
-          <p:cNvPr id="91" name="Google Shape;91;p3:notes">
+          <p:cNvPr id="473" name="Google Shape;473;p16:notes">
             <a:extLst>
               <a:ext uri="{FF2B5EF4-FFF2-40B4-BE49-F238E27FC236}">
-                <a16:creationId xmlns:a16="http://schemas.microsoft.com/office/drawing/2014/main" id="{0AA3BA3D-B0A6-CC9F-0822-2554E88C8A5A}"/>
+                <a16:creationId xmlns:a16="http://schemas.microsoft.com/office/drawing/2014/main" id="{B9AEE057-00C3-D250-CA9A-BFEC29C47AC7}"/>
               </a:ext>
             </a:extLst>
           </p:cNvPr>
@@ -1106,10 +999,10 @@
       </p:sp>
       <p:sp>
         <p:nvSpPr>
-          <p:cNvPr id="92" name="Google Shape;92;p3:notes">
+          <p:cNvPr id="474" name="Google Shape;474;p16:notes">
             <a:extLst>
               <a:ext uri="{FF2B5EF4-FFF2-40B4-BE49-F238E27FC236}">
-                <a16:creationId xmlns:a16="http://schemas.microsoft.com/office/drawing/2014/main" id="{7969DAC9-9D83-8A09-9DD8-315B2B8D5284}"/>
+                <a16:creationId xmlns:a16="http://schemas.microsoft.com/office/drawing/2014/main" id="{D8D216EE-B44B-01F0-A4C3-997030828C44}"/>
               </a:ext>
             </a:extLst>
           </p:cNvPr>
@@ -1154,243 +1047,7 @@
     </p:spTree>
     <p:extLst>
       <p:ext uri="{BB962C8B-B14F-4D97-AF65-F5344CB8AC3E}">
-        <p14:creationId xmlns:p14="http://schemas.microsoft.com/office/powerpoint/2010/main" val="2984385096"/>
-      </p:ext>
-    </p:extLst>
-  </p:cSld>
-  <p:clrMapOvr>
-    <a:masterClrMapping/>
-  </p:clrMapOvr>
-</p:notes>
-</file>
-
-<file path=ppt/notesSlides/notesSlide5.xml><?xml version="1.0" encoding="utf-8"?>
-<p:notes xmlns:a="http://schemas.openxmlformats.org/drawingml/2006/main" xmlns:r="http://schemas.openxmlformats.org/officeDocument/2006/relationships" xmlns:p="http://schemas.openxmlformats.org/presentationml/2006/main" showMasterSp="0" showMasterPhAnim="0">
-  <p:cSld>
-    <p:spTree>
-      <p:nvGrpSpPr>
-        <p:cNvPr id="1" name="Shape 90"/>
-        <p:cNvGrpSpPr/>
-        <p:nvPr/>
-      </p:nvGrpSpPr>
-      <p:grpSpPr>
-        <a:xfrm>
-          <a:off x="0" y="0"/>
-          <a:ext cx="0" cy="0"/>
-          <a:chOff x="0" y="0"/>
-          <a:chExt cx="0" cy="0"/>
-        </a:xfrm>
-      </p:grpSpPr>
-      <p:sp>
-        <p:nvSpPr>
-          <p:cNvPr id="91" name="Google Shape;91;p3:notes"/>
-          <p:cNvSpPr txBox="1">
-            <a:spLocks noGrp="1"/>
-          </p:cNvSpPr>
-          <p:nvPr>
-            <p:ph type="body" idx="1"/>
-          </p:nvPr>
-        </p:nvSpPr>
-        <p:spPr>
-          <a:xfrm>
-            <a:off x="685800" y="4343400"/>
-            <a:ext cx="5486400" cy="4114800"/>
-          </a:xfrm>
-          <a:prstGeom prst="rect">
-            <a:avLst/>
-          </a:prstGeom>
-        </p:spPr>
-        <p:txBody>
-          <a:bodyPr spcFirstLastPara="1" wrap="square" lIns="91425" tIns="91425" rIns="91425" bIns="91425" anchor="t" anchorCtr="0">
-            <a:noAutofit/>
-          </a:bodyPr>
-          <a:lstStyle/>
-          <a:p>
-            <a:pPr marL="0" lvl="0" indent="0" algn="l" rtl="0">
-              <a:spcBef>
-                <a:spcPts val="0"/>
-              </a:spcBef>
-              <a:spcAft>
-                <a:spcPts val="0"/>
-              </a:spcAft>
-              <a:buNone/>
-            </a:pPr>
-            <a:endParaRPr/>
-          </a:p>
-        </p:txBody>
-      </p:sp>
-      <p:sp>
-        <p:nvSpPr>
-          <p:cNvPr id="92" name="Google Shape;92;p3:notes"/>
-          <p:cNvSpPr>
-            <a:spLocks noGrp="1" noRot="1" noChangeAspect="1"/>
-          </p:cNvSpPr>
-          <p:nvPr>
-            <p:ph type="sldImg" idx="2"/>
-          </p:nvPr>
-        </p:nvSpPr>
-        <p:spPr>
-          <a:xfrm>
-            <a:off x="381000" y="685800"/>
-            <a:ext cx="6096000" cy="3429000"/>
-          </a:xfrm>
-          <a:custGeom>
-            <a:avLst/>
-            <a:gdLst/>
-            <a:ahLst/>
-            <a:cxnLst/>
-            <a:rect l="l" t="t" r="r" b="b"/>
-            <a:pathLst>
-              <a:path w="120000" h="120000" extrusionOk="0">
-                <a:moveTo>
-                  <a:pt x="0" y="0"/>
-                </a:moveTo>
-                <a:lnTo>
-                  <a:pt x="120000" y="0"/>
-                </a:lnTo>
-                <a:lnTo>
-                  <a:pt x="120000" y="120000"/>
-                </a:lnTo>
-                <a:lnTo>
-                  <a:pt x="0" y="120000"/>
-                </a:lnTo>
-                <a:close/>
-              </a:path>
-            </a:pathLst>
-          </a:custGeom>
-        </p:spPr>
-      </p:sp>
-    </p:spTree>
-    <p:extLst>
-      <p:ext uri="{BB962C8B-B14F-4D97-AF65-F5344CB8AC3E}">
-        <p14:creationId xmlns:p14="http://schemas.microsoft.com/office/powerpoint/2010/main" val="113450285"/>
-      </p:ext>
-    </p:extLst>
-  </p:cSld>
-  <p:clrMapOvr>
-    <a:masterClrMapping/>
-  </p:clrMapOvr>
-</p:notes>
-</file>
-
-<file path=ppt/notesSlides/notesSlide6.xml><?xml version="1.0" encoding="utf-8"?>
-<p:notes xmlns:a="http://schemas.openxmlformats.org/drawingml/2006/main" xmlns:r="http://schemas.openxmlformats.org/officeDocument/2006/relationships" xmlns:p="http://schemas.openxmlformats.org/presentationml/2006/main" showMasterSp="0" showMasterPhAnim="0">
-  <p:cSld>
-    <p:spTree>
-      <p:nvGrpSpPr>
-        <p:cNvPr id="1" name="Shape 90">
-          <a:extLst>
-            <a:ext uri="{FF2B5EF4-FFF2-40B4-BE49-F238E27FC236}">
-              <a16:creationId xmlns:a16="http://schemas.microsoft.com/office/drawing/2014/main" id="{2BC1271B-C0FA-0E8C-386D-652864F18742}"/>
-            </a:ext>
-          </a:extLst>
-        </p:cNvPr>
-        <p:cNvGrpSpPr/>
-        <p:nvPr/>
-      </p:nvGrpSpPr>
-      <p:grpSpPr>
-        <a:xfrm>
-          <a:off x="0" y="0"/>
-          <a:ext cx="0" cy="0"/>
-          <a:chOff x="0" y="0"/>
-          <a:chExt cx="0" cy="0"/>
-        </a:xfrm>
-      </p:grpSpPr>
-      <p:sp>
-        <p:nvSpPr>
-          <p:cNvPr id="91" name="Google Shape;91;p3:notes">
-            <a:extLst>
-              <a:ext uri="{FF2B5EF4-FFF2-40B4-BE49-F238E27FC236}">
-                <a16:creationId xmlns:a16="http://schemas.microsoft.com/office/drawing/2014/main" id="{D810B27D-A3FF-1C67-CD4F-32032D35B143}"/>
-              </a:ext>
-            </a:extLst>
-          </p:cNvPr>
-          <p:cNvSpPr txBox="1">
-            <a:spLocks noGrp="1"/>
-          </p:cNvSpPr>
-          <p:nvPr>
-            <p:ph type="body" idx="1"/>
-          </p:nvPr>
-        </p:nvSpPr>
-        <p:spPr>
-          <a:xfrm>
-            <a:off x="685800" y="4343400"/>
-            <a:ext cx="5486400" cy="4114800"/>
-          </a:xfrm>
-          <a:prstGeom prst="rect">
-            <a:avLst/>
-          </a:prstGeom>
-        </p:spPr>
-        <p:txBody>
-          <a:bodyPr spcFirstLastPara="1" wrap="square" lIns="91425" tIns="91425" rIns="91425" bIns="91425" anchor="t" anchorCtr="0">
-            <a:noAutofit/>
-          </a:bodyPr>
-          <a:lstStyle/>
-          <a:p>
-            <a:pPr marL="0" lvl="0" indent="0" algn="l" rtl="0">
-              <a:spcBef>
-                <a:spcPts val="0"/>
-              </a:spcBef>
-              <a:spcAft>
-                <a:spcPts val="0"/>
-              </a:spcAft>
-              <a:buNone/>
-            </a:pPr>
-            <a:endParaRPr/>
-          </a:p>
-        </p:txBody>
-      </p:sp>
-      <p:sp>
-        <p:nvSpPr>
-          <p:cNvPr id="92" name="Google Shape;92;p3:notes">
-            <a:extLst>
-              <a:ext uri="{FF2B5EF4-FFF2-40B4-BE49-F238E27FC236}">
-                <a16:creationId xmlns:a16="http://schemas.microsoft.com/office/drawing/2014/main" id="{1D1D1DD0-0434-D99E-EE1F-543A2146BDD8}"/>
-              </a:ext>
-            </a:extLst>
-          </p:cNvPr>
-          <p:cNvSpPr>
-            <a:spLocks noGrp="1" noRot="1" noChangeAspect="1"/>
-          </p:cNvSpPr>
-          <p:nvPr>
-            <p:ph type="sldImg" idx="2"/>
-          </p:nvPr>
-        </p:nvSpPr>
-        <p:spPr>
-          <a:xfrm>
-            <a:off x="381000" y="685800"/>
-            <a:ext cx="6096000" cy="3429000"/>
-          </a:xfrm>
-          <a:custGeom>
-            <a:avLst/>
-            <a:gdLst/>
-            <a:ahLst/>
-            <a:cxnLst/>
-            <a:rect l="l" t="t" r="r" b="b"/>
-            <a:pathLst>
-              <a:path w="120000" h="120000" extrusionOk="0">
-                <a:moveTo>
-                  <a:pt x="0" y="0"/>
-                </a:moveTo>
-                <a:lnTo>
-                  <a:pt x="120000" y="0"/>
-                </a:lnTo>
-                <a:lnTo>
-                  <a:pt x="120000" y="120000"/>
-                </a:lnTo>
-                <a:lnTo>
-                  <a:pt x="0" y="120000"/>
-                </a:lnTo>
-                <a:close/>
-              </a:path>
-            </a:pathLst>
-          </a:custGeom>
-        </p:spPr>
-      </p:sp>
-    </p:spTree>
-    <p:extLst>
-      <p:ext uri="{BB962C8B-B14F-4D97-AF65-F5344CB8AC3E}">
-        <p14:creationId xmlns:p14="http://schemas.microsoft.com/office/powerpoint/2010/main" val="3524505353"/>
+        <p14:creationId xmlns:p14="http://schemas.microsoft.com/office/powerpoint/2010/main" val="2318813024"/>
       </p:ext>
     </p:extLst>
   </p:cSld>
@@ -11526,7 +11183,7 @@
     </p:bg>
     <p:spTree>
       <p:nvGrpSpPr>
-        <p:cNvPr id="1" name="Shape 93"/>
+        <p:cNvPr id="1" name="Shape 540"/>
         <p:cNvGrpSpPr/>
         <p:nvPr/>
       </p:nvGrpSpPr>
@@ -11540,13 +11197,13 @@
       </p:grpSpPr>
       <p:grpSp>
         <p:nvGrpSpPr>
-          <p:cNvPr id="94" name="Google Shape;94;p14"/>
+          <p:cNvPr id="541" name="Google Shape;541;p30"/>
           <p:cNvGrpSpPr/>
           <p:nvPr/>
         </p:nvGrpSpPr>
         <p:grpSpPr>
           <a:xfrm>
-            <a:off x="498283" y="353622"/>
+            <a:off x="498282" y="391350"/>
             <a:ext cx="17291434" cy="9435095"/>
             <a:chOff x="0" y="-38100"/>
             <a:chExt cx="4554123" cy="2484963"/>
@@ -11554,7 +11211,7 @@
         </p:grpSpPr>
         <p:sp>
           <p:nvSpPr>
-            <p:cNvPr id="95" name="Google Shape;95;p14"/>
+            <p:cNvPr id="542" name="Google Shape;542;p30"/>
             <p:cNvSpPr/>
             <p:nvPr/>
           </p:nvSpPr>
@@ -11612,7 +11269,7 @@
         </p:sp>
         <p:sp>
           <p:nvSpPr>
-            <p:cNvPr id="96" name="Google Shape;96;p14"/>
+            <p:cNvPr id="543" name="Google Shape;543;p30"/>
             <p:cNvSpPr txBox="1"/>
             <p:nvPr/>
           </p:nvSpPr>
@@ -11662,7 +11319,7 @@
       </p:grpSp>
       <p:pic>
         <p:nvPicPr>
-          <p:cNvPr id="97" name="Google Shape;97;p14"/>
+          <p:cNvPr id="544" name="Google Shape;544;p30"/>
           <p:cNvPicPr preferRelativeResize="0"/>
           <p:nvPr/>
         </p:nvPicPr>
@@ -11676,64 +11333,8 @@
         </p:blipFill>
         <p:spPr>
           <a:xfrm>
-            <a:off x="12933083" y="3380592"/>
-            <a:ext cx="3185775" cy="3185775"/>
-          </a:xfrm>
-          <a:prstGeom prst="rect">
-            <a:avLst/>
-          </a:prstGeom>
-          <a:noFill/>
-          <a:ln>
-            <a:noFill/>
-          </a:ln>
-        </p:spPr>
-      </p:pic>
-      <p:pic>
-        <p:nvPicPr>
-          <p:cNvPr id="98" name="Google Shape;98;p14"/>
-          <p:cNvPicPr preferRelativeResize="0"/>
-          <p:nvPr/>
-        </p:nvPicPr>
-        <p:blipFill>
-          <a:blip r:embed="rId3">
-            <a:alphaModFix/>
-          </a:blip>
-          <a:stretch>
-            <a:fillRect/>
-          </a:stretch>
-        </p:blipFill>
-        <p:spPr>
-          <a:xfrm>
-            <a:off x="7503721" y="3380592"/>
-            <a:ext cx="3185775" cy="3185775"/>
-          </a:xfrm>
-          <a:prstGeom prst="rect">
-            <a:avLst/>
-          </a:prstGeom>
-          <a:noFill/>
-          <a:ln>
-            <a:noFill/>
-          </a:ln>
-        </p:spPr>
-      </p:pic>
-      <p:pic>
-        <p:nvPicPr>
-          <p:cNvPr id="99" name="Google Shape;99;p14"/>
-          <p:cNvPicPr preferRelativeResize="0"/>
-          <p:nvPr/>
-        </p:nvPicPr>
-        <p:blipFill>
-          <a:blip r:embed="rId3">
-            <a:alphaModFix/>
-          </a:blip>
-          <a:stretch>
-            <a:fillRect/>
-          </a:stretch>
-        </p:blipFill>
-        <p:spPr>
-          <a:xfrm>
-            <a:off x="2074358" y="3380592"/>
-            <a:ext cx="3185775" cy="3185775"/>
+            <a:off x="11805200" y="5594050"/>
+            <a:ext cx="10831351" cy="6477025"/>
           </a:xfrm>
           <a:prstGeom prst="rect">
             <a:avLst/>
@@ -11746,14 +11347,14 @@
       </p:pic>
       <p:sp>
         <p:nvSpPr>
-          <p:cNvPr id="100" name="Google Shape;100;p14"/>
+          <p:cNvPr id="546" name="Google Shape;546;p30"/>
           <p:cNvSpPr txBox="1"/>
           <p:nvPr/>
         </p:nvSpPr>
         <p:spPr>
           <a:xfrm>
-            <a:off x="1697662" y="1096299"/>
-            <a:ext cx="14892600" cy="1702902"/>
+            <a:off x="2455652" y="1407146"/>
+            <a:ext cx="13376695" cy="1218795"/>
           </a:xfrm>
           <a:prstGeom prst="rect">
             <a:avLst/>
@@ -11782,31 +11383,31 @@
               <a:buNone/>
             </a:pPr>
             <a:r>
-              <a:rPr lang="en-US" sz="10060" b="1" i="0" u="none" strike="noStrike" cap="none" dirty="0">
+              <a:rPr lang="en-US" sz="7200" b="1" i="0" u="none" strike="noStrike" cap="none" dirty="0">
                 <a:solidFill>
-                  <a:srgbClr val="BCFFB9"/>
+                  <a:srgbClr val="FDED8F"/>
                 </a:solidFill>
                 <a:latin typeface="League Spartan"/>
                 <a:ea typeface="League Spartan"/>
                 <a:cs typeface="League Spartan"/>
                 <a:sym typeface="League Spartan"/>
               </a:rPr>
-              <a:t>FRONT-END</a:t>
+              <a:t>SOBRE O E-COMMERCE</a:t>
             </a:r>
-            <a:endParaRPr sz="3700" dirty="0"/>
+            <a:endParaRPr lang="en-US" sz="7200" dirty="0"/>
           </a:p>
         </p:txBody>
       </p:sp>
       <p:sp>
         <p:nvSpPr>
-          <p:cNvPr id="104" name="Google Shape;104;p14"/>
+          <p:cNvPr id="547" name="Google Shape;547;p30"/>
           <p:cNvSpPr txBox="1"/>
           <p:nvPr/>
         </p:nvSpPr>
         <p:spPr>
           <a:xfrm>
-            <a:off x="475548" y="6795865"/>
-            <a:ext cx="6399900" cy="639983"/>
+            <a:off x="4517568" y="3497076"/>
+            <a:ext cx="9252857" cy="2223879"/>
           </a:xfrm>
           <a:prstGeom prst="rect">
             <a:avLst/>
@@ -11824,7 +11425,7 @@
           <a:p>
             <a:pPr marL="0" marR="0" lvl="0" indent="0" algn="ctr" rtl="0">
               <a:lnSpc>
-                <a:spcPct val="130009"/>
+                <a:spcPct val="140000"/>
               </a:lnSpc>
               <a:spcBef>
                 <a:spcPts val="0"/>
@@ -11835,31 +11436,39 @@
               <a:buNone/>
             </a:pPr>
             <a:r>
-              <a:rPr lang="en-US" sz="3199" b="1" i="0" u="none" strike="noStrike" cap="none" dirty="0">
+              <a:rPr lang="pt-BR" sz="3441" b="1" i="0" u="none" strike="noStrike" cap="none" dirty="0">
                 <a:solidFill>
-                  <a:srgbClr val="FF779A"/>
+                  <a:srgbClr val="FFFFFF"/>
                 </a:solidFill>
                 <a:latin typeface="Blinker"/>
                 <a:ea typeface="Blinker"/>
                 <a:cs typeface="Blinker"/>
                 <a:sym typeface="Blinker"/>
               </a:rPr>
-              <a:t>HTML5, CSS3</a:t>
+              <a:t>Site de e-commerce voltada à venda de camisetas masculinas e femininas com diferentes cores e tamanhos com foco nas estampas.</a:t>
             </a:r>
-            <a:endParaRPr dirty="0"/>
+            <a:endParaRPr lang="en-US" dirty="0"/>
           </a:p>
         </p:txBody>
       </p:sp>
-      <p:sp>
-        <p:nvSpPr>
-          <p:cNvPr id="105" name="Google Shape;105;p14"/>
-          <p:cNvSpPr txBox="1"/>
+      <p:pic>
+        <p:nvPicPr>
+          <p:cNvPr id="552" name="Google Shape;552;p30"/>
+          <p:cNvPicPr preferRelativeResize="0"/>
           <p:nvPr/>
-        </p:nvSpPr>
+        </p:nvPicPr>
+        <p:blipFill>
+          <a:blip r:embed="rId4">
+            <a:alphaModFix/>
+          </a:blip>
+          <a:stretch>
+            <a:fillRect/>
+          </a:stretch>
+        </p:blipFill>
         <p:spPr>
           <a:xfrm>
-            <a:off x="5944084" y="6795865"/>
-            <a:ext cx="6399900" cy="639983"/>
+            <a:off x="14851959" y="-4999421"/>
+            <a:ext cx="8267026" cy="8749563"/>
           </a:xfrm>
           <a:prstGeom prst="rect">
             <a:avLst/>
@@ -11869,50 +11478,25 @@
             <a:noFill/>
           </a:ln>
         </p:spPr>
-        <p:txBody>
-          <a:bodyPr spcFirstLastPara="1" wrap="square" lIns="0" tIns="0" rIns="0" bIns="0" anchor="t" anchorCtr="0">
-            <a:spAutoFit/>
-          </a:bodyPr>
-          <a:lstStyle/>
-          <a:p>
-            <a:pPr marL="0" marR="0" lvl="0" indent="0" algn="ctr" rtl="0">
-              <a:lnSpc>
-                <a:spcPct val="130009"/>
-              </a:lnSpc>
-              <a:spcBef>
-                <a:spcPts val="0"/>
-              </a:spcBef>
-              <a:spcAft>
-                <a:spcPts val="0"/>
-              </a:spcAft>
-              <a:buNone/>
-            </a:pPr>
-            <a:r>
-              <a:rPr lang="en-US" sz="3199" b="1" i="0" u="none" strike="noStrike" cap="none" dirty="0">
-                <a:solidFill>
-                  <a:srgbClr val="FF779A"/>
-                </a:solidFill>
-                <a:latin typeface="Blinker"/>
-                <a:ea typeface="Blinker"/>
-                <a:cs typeface="Blinker"/>
-                <a:sym typeface="Blinker"/>
-              </a:rPr>
-              <a:t>ANGULAR</a:t>
-            </a:r>
-            <a:endParaRPr dirty="0"/>
-          </a:p>
-        </p:txBody>
-      </p:sp>
-      <p:sp>
-        <p:nvSpPr>
-          <p:cNvPr id="106" name="Google Shape;106;p14"/>
-          <p:cNvSpPr txBox="1"/>
+      </p:pic>
+      <p:pic>
+        <p:nvPicPr>
+          <p:cNvPr id="553" name="Google Shape;553;p30"/>
+          <p:cNvPicPr preferRelativeResize="0"/>
           <p:nvPr/>
-        </p:nvSpPr>
+        </p:nvPicPr>
+        <p:blipFill>
+          <a:blip r:embed="rId4">
+            <a:alphaModFix/>
+          </a:blip>
+          <a:stretch>
+            <a:fillRect/>
+          </a:stretch>
+        </p:blipFill>
         <p:spPr>
           <a:xfrm>
-            <a:off x="11412620" y="6795865"/>
-            <a:ext cx="6399900" cy="639983"/>
+            <a:off x="-3990980" y="5975045"/>
+            <a:ext cx="8267026" cy="8749563"/>
           </a:xfrm>
           <a:prstGeom prst="rect">
             <a:avLst/>
@@ -11922,91 +11506,16 @@
             <a:noFill/>
           </a:ln>
         </p:spPr>
-        <p:txBody>
-          <a:bodyPr spcFirstLastPara="1" wrap="square" lIns="0" tIns="0" rIns="0" bIns="0" anchor="t" anchorCtr="0">
-            <a:spAutoFit/>
-          </a:bodyPr>
-          <a:lstStyle/>
-          <a:p>
-            <a:pPr marL="0" marR="0" lvl="0" indent="0" algn="ctr" rtl="0">
-              <a:lnSpc>
-                <a:spcPct val="130009"/>
-              </a:lnSpc>
-              <a:spcBef>
-                <a:spcPts val="0"/>
-              </a:spcBef>
-              <a:spcAft>
-                <a:spcPts val="0"/>
-              </a:spcAft>
-              <a:buNone/>
-            </a:pPr>
-            <a:r>
-              <a:rPr lang="en-US" sz="3199" b="1" i="0" u="none" strike="noStrike" cap="none" dirty="0">
-                <a:solidFill>
-                  <a:srgbClr val="FF779A"/>
-                </a:solidFill>
-                <a:latin typeface="Blinker"/>
-                <a:ea typeface="Blinker"/>
-                <a:cs typeface="Blinker"/>
-                <a:sym typeface="Blinker"/>
-              </a:rPr>
-              <a:t>TAILWIND</a:t>
-            </a:r>
-            <a:endParaRPr dirty="0"/>
-          </a:p>
-        </p:txBody>
-      </p:sp>
+      </p:pic>
       <p:pic>
         <p:nvPicPr>
-          <p:cNvPr id="2" name="Imagem 1" descr="Tailwind Css Fill icon - Free Download PNG &amp; SVG | Streamline">
-            <a:extLst>
-              <a:ext uri="{FF2B5EF4-FFF2-40B4-BE49-F238E27FC236}">
-                <a16:creationId xmlns:a16="http://schemas.microsoft.com/office/drawing/2014/main" id="{691EA5C5-5335-7004-2A78-A0289CBA93D2}"/>
-              </a:ext>
-            </a:extLst>
-          </p:cNvPr>
-          <p:cNvPicPr>
-            <a:picLocks noChangeAspect="1"/>
-          </p:cNvPicPr>
+          <p:cNvPr id="554" name="Google Shape;554;p30"/>
+          <p:cNvPicPr preferRelativeResize="0"/>
           <p:nvPr/>
         </p:nvPicPr>
         <p:blipFill>
-          <a:blip r:embed="rId4"/>
-          <a:stretch>
-            <a:fillRect/>
-          </a:stretch>
-        </p:blipFill>
-        <p:spPr>
-          <a:xfrm>
-            <a:off x="13399910" y="3945109"/>
-            <a:ext cx="2252120" cy="2252120"/>
-          </a:xfrm>
-          <a:prstGeom prst="rect">
-            <a:avLst/>
-          </a:prstGeom>
-        </p:spPr>
-      </p:pic>
-      <p:pic>
-        <p:nvPicPr>
-          <p:cNvPr id="6" name="Gráfico 5">
-            <a:extLst>
-              <a:ext uri="{FF2B5EF4-FFF2-40B4-BE49-F238E27FC236}">
-                <a16:creationId xmlns:a16="http://schemas.microsoft.com/office/drawing/2014/main" id="{C16BDB52-4575-53F8-AD03-E4450324A148}"/>
-              </a:ext>
-            </a:extLst>
-          </p:cNvPr>
-          <p:cNvPicPr>
-            <a:picLocks noChangeAspect="1"/>
-          </p:cNvPicPr>
-          <p:nvPr/>
-        </p:nvPicPr>
-        <p:blipFill>
-          <a:blip>
-            <a:extLst>
-              <a:ext uri="{96DAC541-7B7A-43D3-8B79-37D633B846F1}">
-                <asvg:svgBlip xmlns:asvg="http://schemas.microsoft.com/office/drawing/2016/SVG/main" r:embed="rId5"/>
-              </a:ext>
-            </a:extLst>
+          <a:blip r:embed="rId3">
+            <a:alphaModFix/>
           </a:blip>
           <a:stretch>
             <a:fillRect/>
@@ -12014,45 +11523,24 @@
         </p:blipFill>
         <p:spPr>
           <a:xfrm>
-            <a:off x="8078713" y="4005507"/>
-            <a:ext cx="2035790" cy="2035790"/>
+            <a:off x="-4162000" y="-1730275"/>
+            <a:ext cx="9988526" cy="5973024"/>
           </a:xfrm>
           <a:prstGeom prst="rect">
             <a:avLst/>
           </a:prstGeom>
-        </p:spPr>
-      </p:pic>
-      <p:pic>
-        <p:nvPicPr>
-          <p:cNvPr id="9" name="Imagem 8">
-            <a:extLst>
-              <a:ext uri="{FF2B5EF4-FFF2-40B4-BE49-F238E27FC236}">
-                <a16:creationId xmlns:a16="http://schemas.microsoft.com/office/drawing/2014/main" id="{EDFD4FA5-F71D-2307-66E2-7411CDCA89D6}"/>
-              </a:ext>
-            </a:extLst>
-          </p:cNvPr>
-          <p:cNvPicPr>
-            <a:picLocks noChangeAspect="1"/>
-          </p:cNvPicPr>
-          <p:nvPr/>
-        </p:nvPicPr>
-        <p:blipFill>
-          <a:blip r:embed="rId6"/>
-          <a:stretch>
-            <a:fillRect/>
-          </a:stretch>
-        </p:blipFill>
-        <p:spPr>
-          <a:xfrm>
-            <a:off x="2722162" y="4020249"/>
-            <a:ext cx="1906460" cy="1906460"/>
-          </a:xfrm>
-          <a:prstGeom prst="rect">
-            <a:avLst/>
-          </a:prstGeom>
+          <a:noFill/>
+          <a:ln>
+            <a:noFill/>
+          </a:ln>
         </p:spPr>
       </p:pic>
     </p:spTree>
+    <p:extLst>
+      <p:ext uri="{BB962C8B-B14F-4D97-AF65-F5344CB8AC3E}">
+        <p14:creationId xmlns:p14="http://schemas.microsoft.com/office/powerpoint/2010/main" val="2887058372"/>
+      </p:ext>
+    </p:extLst>
   </p:cSld>
   <p:clrMapOvr>
     <a:masterClrMapping/>
@@ -12073,457 +11561,10 @@
     </p:bg>
     <p:spTree>
       <p:nvGrpSpPr>
-        <p:cNvPr id="1" name="Shape 93"/>
-        <p:cNvGrpSpPr/>
-        <p:nvPr/>
-      </p:nvGrpSpPr>
-      <p:grpSpPr>
-        <a:xfrm>
-          <a:off x="0" y="0"/>
-          <a:ext cx="0" cy="0"/>
-          <a:chOff x="0" y="0"/>
-          <a:chExt cx="0" cy="0"/>
-        </a:xfrm>
-      </p:grpSpPr>
-      <p:grpSp>
-        <p:nvGrpSpPr>
-          <p:cNvPr id="94" name="Google Shape;94;p14"/>
-          <p:cNvGrpSpPr/>
-          <p:nvPr/>
-        </p:nvGrpSpPr>
-        <p:grpSpPr>
-          <a:xfrm>
-            <a:off x="498283" y="353622"/>
-            <a:ext cx="17291434" cy="9435095"/>
-            <a:chOff x="0" y="-38100"/>
-            <a:chExt cx="4554123" cy="2484963"/>
-          </a:xfrm>
-        </p:grpSpPr>
-        <p:sp>
-          <p:nvSpPr>
-            <p:cNvPr id="95" name="Google Shape;95;p14"/>
-            <p:cNvSpPr/>
-            <p:nvPr/>
-          </p:nvSpPr>
-          <p:spPr>
-            <a:xfrm>
-              <a:off x="0" y="0"/>
-              <a:ext cx="4554122" cy="2446863"/>
-            </a:xfrm>
-            <a:custGeom>
-              <a:avLst/>
-              <a:gdLst/>
-              <a:ahLst/>
-              <a:cxnLst/>
-              <a:rect l="l" t="t" r="r" b="b"/>
-              <a:pathLst>
-                <a:path w="4554122" h="2446863" extrusionOk="0">
-                  <a:moveTo>
-                    <a:pt x="0" y="0"/>
-                  </a:moveTo>
-                  <a:lnTo>
-                    <a:pt x="4554122" y="0"/>
-                  </a:lnTo>
-                  <a:lnTo>
-                    <a:pt x="4554122" y="2446863"/>
-                  </a:lnTo>
-                  <a:lnTo>
-                    <a:pt x="0" y="2446863"/>
-                  </a:lnTo>
-                  <a:close/>
-                </a:path>
-              </a:pathLst>
-            </a:custGeom>
-            <a:solidFill>
-              <a:srgbClr val="000000">
-                <a:alpha val="0"/>
-              </a:srgbClr>
-            </a:solidFill>
-            <a:ln w="123825" cap="sq" cmpd="sng">
-              <a:solidFill>
-                <a:srgbClr val="BCFFB9"/>
-              </a:solidFill>
-              <a:prstDash val="solid"/>
-              <a:miter lim="8000"/>
-              <a:headEnd type="none" w="sm" len="sm"/>
-              <a:tailEnd type="none" w="sm" len="sm"/>
-            </a:ln>
-          </p:spPr>
-          <p:txBody>
-            <a:bodyPr/>
-            <a:lstStyle/>
-            <a:p>
-              <a:endParaRPr lang="pt-BR"/>
-            </a:p>
-          </p:txBody>
-        </p:sp>
-        <p:sp>
-          <p:nvSpPr>
-            <p:cNvPr id="96" name="Google Shape;96;p14"/>
-            <p:cNvSpPr txBox="1"/>
-            <p:nvPr/>
-          </p:nvSpPr>
-          <p:spPr>
-            <a:xfrm>
-              <a:off x="0" y="-38100"/>
-              <a:ext cx="4554123" cy="2484963"/>
-            </a:xfrm>
-            <a:prstGeom prst="rect">
-              <a:avLst/>
-            </a:prstGeom>
-            <a:noFill/>
-            <a:ln>
-              <a:noFill/>
-            </a:ln>
-          </p:spPr>
-          <p:txBody>
-            <a:bodyPr spcFirstLastPara="1" wrap="square" lIns="50800" tIns="50800" rIns="50800" bIns="50800" anchor="ctr" anchorCtr="0">
-              <a:noAutofit/>
-            </a:bodyPr>
-            <a:lstStyle/>
-            <a:p>
-              <a:pPr marL="0" marR="0" lvl="0" indent="0" algn="ctr" rtl="0">
-                <a:lnSpc>
-                  <a:spcPct val="147388"/>
-                </a:lnSpc>
-                <a:spcBef>
-                  <a:spcPts val="0"/>
-                </a:spcBef>
-                <a:spcAft>
-                  <a:spcPts val="0"/>
-                </a:spcAft>
-                <a:buNone/>
-              </a:pPr>
-              <a:endParaRPr sz="1800" b="0" i="0" u="none" strike="noStrike" cap="none">
-                <a:solidFill>
-                  <a:schemeClr val="dk1"/>
-                </a:solidFill>
-                <a:latin typeface="Calibri"/>
-                <a:ea typeface="Calibri"/>
-                <a:cs typeface="Calibri"/>
-                <a:sym typeface="Calibri"/>
-              </a:endParaRPr>
-            </a:p>
-          </p:txBody>
-        </p:sp>
-      </p:grpSp>
-      <p:pic>
-        <p:nvPicPr>
-          <p:cNvPr id="98" name="Google Shape;98;p14"/>
-          <p:cNvPicPr preferRelativeResize="0"/>
-          <p:nvPr/>
-        </p:nvPicPr>
-        <p:blipFill>
-          <a:blip r:embed="rId3">
-            <a:alphaModFix/>
-          </a:blip>
-          <a:stretch>
-            <a:fillRect/>
-          </a:stretch>
-        </p:blipFill>
-        <p:spPr>
-          <a:xfrm>
-            <a:off x="10096794" y="3397217"/>
-            <a:ext cx="3185775" cy="3185775"/>
-          </a:xfrm>
-          <a:prstGeom prst="rect">
-            <a:avLst/>
-          </a:prstGeom>
-          <a:noFill/>
-          <a:ln>
-            <a:noFill/>
-          </a:ln>
-        </p:spPr>
-      </p:pic>
-      <p:pic>
-        <p:nvPicPr>
-          <p:cNvPr id="99" name="Google Shape;99;p14"/>
-          <p:cNvPicPr preferRelativeResize="0"/>
-          <p:nvPr/>
-        </p:nvPicPr>
-        <p:blipFill>
-          <a:blip r:embed="rId3">
-            <a:alphaModFix/>
-          </a:blip>
-          <a:stretch>
-            <a:fillRect/>
-          </a:stretch>
-        </p:blipFill>
-        <p:spPr>
-          <a:xfrm>
-            <a:off x="4667431" y="3397217"/>
-            <a:ext cx="3185775" cy="3185775"/>
-          </a:xfrm>
-          <a:prstGeom prst="rect">
-            <a:avLst/>
-          </a:prstGeom>
-          <a:noFill/>
-          <a:ln>
-            <a:noFill/>
-          </a:ln>
-        </p:spPr>
-      </p:pic>
-      <p:sp>
-        <p:nvSpPr>
-          <p:cNvPr id="100" name="Google Shape;100;p14"/>
-          <p:cNvSpPr txBox="1"/>
-          <p:nvPr/>
-        </p:nvSpPr>
-        <p:spPr>
-          <a:xfrm>
-            <a:off x="1697662" y="1096299"/>
-            <a:ext cx="14892600" cy="1702902"/>
-          </a:xfrm>
-          <a:prstGeom prst="rect">
-            <a:avLst/>
-          </a:prstGeom>
-          <a:noFill/>
-          <a:ln>
-            <a:noFill/>
-          </a:ln>
-        </p:spPr>
-        <p:txBody>
-          <a:bodyPr spcFirstLastPara="1" wrap="square" lIns="0" tIns="0" rIns="0" bIns="0" anchor="t" anchorCtr="0">
-            <a:spAutoFit/>
-          </a:bodyPr>
-          <a:lstStyle/>
-          <a:p>
-            <a:pPr marL="0" marR="0" lvl="0" indent="0" algn="ctr" rtl="0">
-              <a:lnSpc>
-                <a:spcPct val="110000"/>
-              </a:lnSpc>
-              <a:spcBef>
-                <a:spcPts val="0"/>
-              </a:spcBef>
-              <a:spcAft>
-                <a:spcPts val="0"/>
-              </a:spcAft>
-              <a:buNone/>
-            </a:pPr>
-            <a:r>
-              <a:rPr lang="en-US" sz="10060" b="1" dirty="0">
-                <a:solidFill>
-                  <a:srgbClr val="BCFFB9"/>
-                </a:solidFill>
-                <a:latin typeface="League Spartan"/>
-                <a:ea typeface="League Spartan"/>
-                <a:cs typeface="League Spartan"/>
-                <a:sym typeface="League Spartan"/>
-              </a:rPr>
-              <a:t>BACK</a:t>
-            </a:r>
-            <a:r>
-              <a:rPr lang="en-US" sz="10060" b="1" i="0" u="none" strike="noStrike" cap="none" dirty="0">
-                <a:solidFill>
-                  <a:srgbClr val="BCFFB9"/>
-                </a:solidFill>
-                <a:latin typeface="League Spartan"/>
-                <a:ea typeface="League Spartan"/>
-                <a:cs typeface="League Spartan"/>
-                <a:sym typeface="League Spartan"/>
-              </a:rPr>
-              <a:t>-END</a:t>
-            </a:r>
-            <a:endParaRPr sz="3700" dirty="0"/>
-          </a:p>
-        </p:txBody>
-      </p:sp>
-      <p:sp>
-        <p:nvSpPr>
-          <p:cNvPr id="104" name="Google Shape;104;p14"/>
-          <p:cNvSpPr txBox="1"/>
-          <p:nvPr/>
-        </p:nvSpPr>
-        <p:spPr>
-          <a:xfrm>
-            <a:off x="3068621" y="6812490"/>
-            <a:ext cx="6399900" cy="639983"/>
-          </a:xfrm>
-          <a:prstGeom prst="rect">
-            <a:avLst/>
-          </a:prstGeom>
-          <a:noFill/>
-          <a:ln>
-            <a:noFill/>
-          </a:ln>
-        </p:spPr>
-        <p:txBody>
-          <a:bodyPr spcFirstLastPara="1" wrap="square" lIns="0" tIns="0" rIns="0" bIns="0" anchor="t" anchorCtr="0">
-            <a:spAutoFit/>
-          </a:bodyPr>
-          <a:lstStyle/>
-          <a:p>
-            <a:pPr marL="0" marR="0" lvl="0" indent="0" algn="ctr" rtl="0">
-              <a:lnSpc>
-                <a:spcPct val="130009"/>
-              </a:lnSpc>
-              <a:spcBef>
-                <a:spcPts val="0"/>
-              </a:spcBef>
-              <a:spcAft>
-                <a:spcPts val="0"/>
-              </a:spcAft>
-              <a:buNone/>
-            </a:pPr>
-            <a:r>
-              <a:rPr lang="en-US" sz="3199" b="1" i="0" u="none" strike="noStrike" cap="none" dirty="0">
-                <a:solidFill>
-                  <a:srgbClr val="FF779A"/>
-                </a:solidFill>
-                <a:latin typeface="Blinker"/>
-                <a:ea typeface="Blinker"/>
-                <a:cs typeface="Blinker"/>
-                <a:sym typeface="Blinker"/>
-              </a:rPr>
-              <a:t>C#</a:t>
-            </a:r>
-            <a:endParaRPr dirty="0"/>
-          </a:p>
-        </p:txBody>
-      </p:sp>
-      <p:sp>
-        <p:nvSpPr>
-          <p:cNvPr id="105" name="Google Shape;105;p14"/>
-          <p:cNvSpPr txBox="1"/>
-          <p:nvPr/>
-        </p:nvSpPr>
-        <p:spPr>
-          <a:xfrm>
-            <a:off x="8537157" y="6812490"/>
-            <a:ext cx="6399900" cy="639983"/>
-          </a:xfrm>
-          <a:prstGeom prst="rect">
-            <a:avLst/>
-          </a:prstGeom>
-          <a:noFill/>
-          <a:ln>
-            <a:noFill/>
-          </a:ln>
-        </p:spPr>
-        <p:txBody>
-          <a:bodyPr spcFirstLastPara="1" wrap="square" lIns="0" tIns="0" rIns="0" bIns="0" anchor="t" anchorCtr="0">
-            <a:spAutoFit/>
-          </a:bodyPr>
-          <a:lstStyle/>
-          <a:p>
-            <a:pPr marL="0" marR="0" lvl="0" indent="0" algn="ctr" rtl="0">
-              <a:lnSpc>
-                <a:spcPct val="130009"/>
-              </a:lnSpc>
-              <a:spcBef>
-                <a:spcPts val="0"/>
-              </a:spcBef>
-              <a:spcAft>
-                <a:spcPts val="0"/>
-              </a:spcAft>
-              <a:buNone/>
-            </a:pPr>
-            <a:r>
-              <a:rPr lang="en-US" sz="3199" b="1" i="0" u="none" strike="noStrike" cap="none" dirty="0">
-                <a:solidFill>
-                  <a:srgbClr val="FF779A"/>
-                </a:solidFill>
-                <a:latin typeface="Blinker"/>
-                <a:ea typeface="Blinker"/>
-                <a:cs typeface="Blinker"/>
-                <a:sym typeface="Blinker"/>
-              </a:rPr>
-              <a:t>ASP.NET CORE </a:t>
-            </a:r>
-            <a:endParaRPr dirty="0"/>
-          </a:p>
-        </p:txBody>
-      </p:sp>
-      <p:pic>
-        <p:nvPicPr>
-          <p:cNvPr id="4" name="Imagem 3">
-            <a:extLst>
-              <a:ext uri="{FF2B5EF4-FFF2-40B4-BE49-F238E27FC236}">
-                <a16:creationId xmlns:a16="http://schemas.microsoft.com/office/drawing/2014/main" id="{2F3BAD41-A5A0-E1F4-E6BE-F9DE09FA7B19}"/>
-              </a:ext>
-            </a:extLst>
-          </p:cNvPr>
-          <p:cNvPicPr>
-            <a:picLocks noChangeAspect="1"/>
-          </p:cNvPicPr>
-          <p:nvPr/>
-        </p:nvPicPr>
-        <p:blipFill>
-          <a:blip r:embed="rId4"/>
-          <a:stretch>
-            <a:fillRect/>
-          </a:stretch>
-        </p:blipFill>
-        <p:spPr>
-          <a:xfrm>
-            <a:off x="5084583" y="3808612"/>
-            <a:ext cx="2351469" cy="2351469"/>
-          </a:xfrm>
-          <a:prstGeom prst="rect">
-            <a:avLst/>
-          </a:prstGeom>
-        </p:spPr>
-      </p:pic>
-      <p:pic>
-        <p:nvPicPr>
-          <p:cNvPr id="7" name="Imagem 6">
-            <a:extLst>
-              <a:ext uri="{FF2B5EF4-FFF2-40B4-BE49-F238E27FC236}">
-                <a16:creationId xmlns:a16="http://schemas.microsoft.com/office/drawing/2014/main" id="{3448EA69-476F-CC4A-0B1C-87A0358BB8F2}"/>
-              </a:ext>
-            </a:extLst>
-          </p:cNvPr>
-          <p:cNvPicPr>
-            <a:picLocks noChangeAspect="1"/>
-          </p:cNvPicPr>
-          <p:nvPr/>
-        </p:nvPicPr>
-        <p:blipFill>
-          <a:blip r:embed="rId5"/>
-          <a:stretch>
-            <a:fillRect/>
-          </a:stretch>
-        </p:blipFill>
-        <p:spPr>
-          <a:xfrm>
-            <a:off x="10911249" y="4292737"/>
-            <a:ext cx="1556863" cy="1556863"/>
-          </a:xfrm>
-          <a:prstGeom prst="rect">
-            <a:avLst/>
-          </a:prstGeom>
-        </p:spPr>
-      </p:pic>
-    </p:spTree>
-    <p:extLst>
-      <p:ext uri="{BB962C8B-B14F-4D97-AF65-F5344CB8AC3E}">
-        <p14:creationId xmlns:p14="http://schemas.microsoft.com/office/powerpoint/2010/main" val="2653301279"/>
-      </p:ext>
-    </p:extLst>
-  </p:cSld>
-  <p:clrMapOvr>
-    <a:masterClrMapping/>
-  </p:clrMapOvr>
-</p:sld>
-</file>
-
-<file path=ppt/slides/slide4.xml><?xml version="1.0" encoding="utf-8"?>
-<p:sld xmlns:a="http://schemas.openxmlformats.org/drawingml/2006/main" xmlns:r="http://schemas.openxmlformats.org/officeDocument/2006/relationships" xmlns:p="http://schemas.openxmlformats.org/presentationml/2006/main">
-  <p:cSld>
-    <p:bg>
-      <p:bgPr>
-        <a:solidFill>
-          <a:srgbClr val="343F7F"/>
-        </a:solidFill>
-        <a:effectLst/>
-      </p:bgPr>
-    </p:bg>
-    <p:spTree>
-      <p:nvGrpSpPr>
-        <p:cNvPr id="1" name="Shape 93">
+        <p:cNvPr id="1" name="Shape 475">
           <a:extLst>
             <a:ext uri="{FF2B5EF4-FFF2-40B4-BE49-F238E27FC236}">
-              <a16:creationId xmlns:a16="http://schemas.microsoft.com/office/drawing/2014/main" id="{A13F275D-F714-F172-9A64-D5883C2D97FF}"/>
+              <a16:creationId xmlns:a16="http://schemas.microsoft.com/office/drawing/2014/main" id="{C61B2CB2-ABAB-DA18-B9A7-4AB652444821}"/>
             </a:ext>
           </a:extLst>
         </p:cNvPr>
@@ -12540,10 +11581,10 @@
       </p:grpSpPr>
       <p:grpSp>
         <p:nvGrpSpPr>
-          <p:cNvPr id="94" name="Google Shape;94;p14">
+          <p:cNvPr id="476" name="Google Shape;476;p27">
             <a:extLst>
               <a:ext uri="{FF2B5EF4-FFF2-40B4-BE49-F238E27FC236}">
-                <a16:creationId xmlns:a16="http://schemas.microsoft.com/office/drawing/2014/main" id="{C4528C22-E081-A3F1-6E8D-341C48D59FDC}"/>
+                <a16:creationId xmlns:a16="http://schemas.microsoft.com/office/drawing/2014/main" id="{B9996A41-F1FD-B936-A8D4-F9E5153CC9F3}"/>
               </a:ext>
             </a:extLst>
           </p:cNvPr>
@@ -12560,10 +11601,10 @@
         </p:grpSpPr>
         <p:sp>
           <p:nvSpPr>
-            <p:cNvPr id="95" name="Google Shape;95;p14">
+            <p:cNvPr id="477" name="Google Shape;477;p27">
               <a:extLst>
                 <a:ext uri="{FF2B5EF4-FFF2-40B4-BE49-F238E27FC236}">
-                  <a16:creationId xmlns:a16="http://schemas.microsoft.com/office/drawing/2014/main" id="{3DCBB1C8-9D35-3669-B0D1-A2A2F89A4459}"/>
+                  <a16:creationId xmlns:a16="http://schemas.microsoft.com/office/drawing/2014/main" id="{5EFA0D6B-D6F0-171A-FFA7-F25893214955}"/>
                 </a:ext>
               </a:extLst>
             </p:cNvPr>
@@ -12624,10 +11665,10 @@
         </p:sp>
         <p:sp>
           <p:nvSpPr>
-            <p:cNvPr id="96" name="Google Shape;96;p14">
+            <p:cNvPr id="478" name="Google Shape;478;p27">
               <a:extLst>
                 <a:ext uri="{FF2B5EF4-FFF2-40B4-BE49-F238E27FC236}">
-                  <a16:creationId xmlns:a16="http://schemas.microsoft.com/office/drawing/2014/main" id="{860CB03B-8449-10E9-BDA9-867B0EE35F58}"/>
+                  <a16:creationId xmlns:a16="http://schemas.microsoft.com/office/drawing/2014/main" id="{63EA8496-2629-B986-5DCB-661891E13C43}"/>
                 </a:ext>
               </a:extLst>
             </p:cNvPr>
@@ -12678,373 +11719,42 @@
           </p:txBody>
         </p:sp>
       </p:grpSp>
-      <p:pic>
-        <p:nvPicPr>
-          <p:cNvPr id="98" name="Google Shape;98;p14">
+      <p:grpSp>
+        <p:nvGrpSpPr>
+          <p:cNvPr id="479" name="Google Shape;479;p27">
             <a:extLst>
               <a:ext uri="{FF2B5EF4-FFF2-40B4-BE49-F238E27FC236}">
-                <a16:creationId xmlns:a16="http://schemas.microsoft.com/office/drawing/2014/main" id="{39BB20F5-5B84-CA36-A2EE-E887129C22C7}"/>
+                <a16:creationId xmlns:a16="http://schemas.microsoft.com/office/drawing/2014/main" id="{32855101-CCB3-8B3C-E768-F96B526A6A00}"/>
               </a:ext>
             </a:extLst>
           </p:cNvPr>
-          <p:cNvPicPr preferRelativeResize="0"/>
-          <p:nvPr/>
-        </p:nvPicPr>
-        <p:blipFill>
-          <a:blip r:embed="rId3">
-            <a:alphaModFix/>
-          </a:blip>
-          <a:stretch>
-            <a:fillRect/>
-          </a:stretch>
-        </p:blipFill>
-        <p:spPr>
-          <a:xfrm>
-            <a:off x="10096794" y="3397217"/>
-            <a:ext cx="3185775" cy="3185775"/>
-          </a:xfrm>
-          <a:prstGeom prst="rect">
-            <a:avLst/>
-          </a:prstGeom>
-          <a:noFill/>
-          <a:ln>
-            <a:noFill/>
-          </a:ln>
-        </p:spPr>
-      </p:pic>
-      <p:pic>
-        <p:nvPicPr>
-          <p:cNvPr id="99" name="Google Shape;99;p14">
-            <a:extLst>
-              <a:ext uri="{FF2B5EF4-FFF2-40B4-BE49-F238E27FC236}">
-                <a16:creationId xmlns:a16="http://schemas.microsoft.com/office/drawing/2014/main" id="{4AD54B10-AABD-04F7-EB78-5CEE9BEA5CC5}"/>
-              </a:ext>
-            </a:extLst>
-          </p:cNvPr>
-          <p:cNvPicPr preferRelativeResize="0"/>
-          <p:nvPr/>
-        </p:nvPicPr>
-        <p:blipFill>
-          <a:blip r:embed="rId3">
-            <a:alphaModFix/>
-          </a:blip>
-          <a:stretch>
-            <a:fillRect/>
-          </a:stretch>
-        </p:blipFill>
-        <p:spPr>
-          <a:xfrm>
-            <a:off x="4667431" y="3397217"/>
-            <a:ext cx="3185775" cy="3185775"/>
-          </a:xfrm>
-          <a:prstGeom prst="rect">
-            <a:avLst/>
-          </a:prstGeom>
-          <a:noFill/>
-          <a:ln>
-            <a:noFill/>
-          </a:ln>
-        </p:spPr>
-      </p:pic>
-      <p:sp>
-        <p:nvSpPr>
-          <p:cNvPr id="100" name="Google Shape;100;p14">
-            <a:extLst>
-              <a:ext uri="{FF2B5EF4-FFF2-40B4-BE49-F238E27FC236}">
-                <a16:creationId xmlns:a16="http://schemas.microsoft.com/office/drawing/2014/main" id="{43F8DAB3-7009-0E3A-C260-173D9541D602}"/>
-              </a:ext>
-            </a:extLst>
-          </p:cNvPr>
-          <p:cNvSpPr txBox="1"/>
-          <p:nvPr/>
-        </p:nvSpPr>
-        <p:spPr>
-          <a:xfrm>
-            <a:off x="1697662" y="1096299"/>
-            <a:ext cx="14892600" cy="1702902"/>
-          </a:xfrm>
-          <a:prstGeom prst="rect">
-            <a:avLst/>
-          </a:prstGeom>
-          <a:noFill/>
-          <a:ln>
-            <a:noFill/>
-          </a:ln>
-        </p:spPr>
-        <p:txBody>
-          <a:bodyPr spcFirstLastPara="1" wrap="square" lIns="0" tIns="0" rIns="0" bIns="0" anchor="t" anchorCtr="0">
-            <a:spAutoFit/>
-          </a:bodyPr>
-          <a:lstStyle/>
-          <a:p>
-            <a:pPr marL="0" marR="0" lvl="0" indent="0" algn="ctr" rtl="0">
-              <a:lnSpc>
-                <a:spcPct val="110000"/>
-              </a:lnSpc>
-              <a:spcBef>
-                <a:spcPts val="0"/>
-              </a:spcBef>
-              <a:spcAft>
-                <a:spcPts val="0"/>
-              </a:spcAft>
-              <a:buNone/>
-            </a:pPr>
-            <a:r>
-              <a:rPr lang="en-US" sz="10060" b="1" dirty="0">
-                <a:solidFill>
-                  <a:srgbClr val="BCFFB9"/>
-                </a:solidFill>
-                <a:latin typeface="League Spartan"/>
-                <a:ea typeface="League Spartan"/>
-                <a:cs typeface="League Spartan"/>
-                <a:sym typeface="League Spartan"/>
-              </a:rPr>
-              <a:t>IA</a:t>
-            </a:r>
-            <a:endParaRPr sz="3700" dirty="0"/>
-          </a:p>
-        </p:txBody>
-      </p:sp>
-      <p:sp>
-        <p:nvSpPr>
-          <p:cNvPr id="104" name="Google Shape;104;p14">
-            <a:extLst>
-              <a:ext uri="{FF2B5EF4-FFF2-40B4-BE49-F238E27FC236}">
-                <a16:creationId xmlns:a16="http://schemas.microsoft.com/office/drawing/2014/main" id="{CDC78F27-77E3-EBED-B754-C173ADA1C6A5}"/>
-              </a:ext>
-            </a:extLst>
-          </p:cNvPr>
-          <p:cNvSpPr txBox="1"/>
-          <p:nvPr/>
-        </p:nvSpPr>
-        <p:spPr>
-          <a:xfrm>
-            <a:off x="3068621" y="6812490"/>
-            <a:ext cx="6399900" cy="639983"/>
-          </a:xfrm>
-          <a:prstGeom prst="rect">
-            <a:avLst/>
-          </a:prstGeom>
-          <a:noFill/>
-          <a:ln>
-            <a:noFill/>
-          </a:ln>
-        </p:spPr>
-        <p:txBody>
-          <a:bodyPr spcFirstLastPara="1" wrap="square" lIns="0" tIns="0" rIns="0" bIns="0" anchor="t" anchorCtr="0">
-            <a:spAutoFit/>
-          </a:bodyPr>
-          <a:lstStyle/>
-          <a:p>
-            <a:pPr marL="0" marR="0" lvl="0" indent="0" algn="ctr" rtl="0">
-              <a:lnSpc>
-                <a:spcPct val="130009"/>
-              </a:lnSpc>
-              <a:spcBef>
-                <a:spcPts val="0"/>
-              </a:spcBef>
-              <a:spcAft>
-                <a:spcPts val="0"/>
-              </a:spcAft>
-              <a:buNone/>
-            </a:pPr>
-            <a:r>
-              <a:rPr lang="en-US" sz="3199" b="1" i="0" u="none" strike="noStrike" cap="none" dirty="0">
-                <a:solidFill>
-                  <a:srgbClr val="FF779A"/>
-                </a:solidFill>
-                <a:latin typeface="Blinker"/>
-                <a:ea typeface="Blinker"/>
-                <a:cs typeface="Blinker"/>
-                <a:sym typeface="Blinker"/>
-              </a:rPr>
-              <a:t>CHATGPT</a:t>
-            </a:r>
-            <a:endParaRPr dirty="0"/>
-          </a:p>
-        </p:txBody>
-      </p:sp>
-      <p:sp>
-        <p:nvSpPr>
-          <p:cNvPr id="105" name="Google Shape;105;p14">
-            <a:extLst>
-              <a:ext uri="{FF2B5EF4-FFF2-40B4-BE49-F238E27FC236}">
-                <a16:creationId xmlns:a16="http://schemas.microsoft.com/office/drawing/2014/main" id="{8FD26AC1-8CD0-AA9F-0DFB-2A7A73D51EDA}"/>
-              </a:ext>
-            </a:extLst>
-          </p:cNvPr>
-          <p:cNvSpPr txBox="1"/>
-          <p:nvPr/>
-        </p:nvSpPr>
-        <p:spPr>
-          <a:xfrm>
-            <a:off x="8537157" y="6812490"/>
-            <a:ext cx="6399900" cy="639983"/>
-          </a:xfrm>
-          <a:prstGeom prst="rect">
-            <a:avLst/>
-          </a:prstGeom>
-          <a:noFill/>
-          <a:ln>
-            <a:noFill/>
-          </a:ln>
-        </p:spPr>
-        <p:txBody>
-          <a:bodyPr spcFirstLastPara="1" wrap="square" lIns="0" tIns="0" rIns="0" bIns="0" anchor="t" anchorCtr="0">
-            <a:spAutoFit/>
-          </a:bodyPr>
-          <a:lstStyle/>
-          <a:p>
-            <a:pPr marL="0" marR="0" lvl="0" indent="0" algn="ctr" rtl="0">
-              <a:lnSpc>
-                <a:spcPct val="130009"/>
-              </a:lnSpc>
-              <a:spcBef>
-                <a:spcPts val="0"/>
-              </a:spcBef>
-              <a:spcAft>
-                <a:spcPts val="0"/>
-              </a:spcAft>
-              <a:buNone/>
-            </a:pPr>
-            <a:r>
-              <a:rPr lang="en-US" sz="3199" b="1" i="0" u="none" strike="noStrike" cap="none" dirty="0">
-                <a:solidFill>
-                  <a:srgbClr val="FF779A"/>
-                </a:solidFill>
-                <a:latin typeface="Blinker"/>
-                <a:ea typeface="Blinker"/>
-                <a:cs typeface="Blinker"/>
-                <a:sym typeface="Blinker"/>
-              </a:rPr>
-              <a:t>GITHUB COPILOT</a:t>
-            </a:r>
-            <a:endParaRPr dirty="0"/>
-          </a:p>
-        </p:txBody>
-      </p:sp>
-      <p:pic>
-        <p:nvPicPr>
-          <p:cNvPr id="3" name="Imagem 2">
-            <a:extLst>
-              <a:ext uri="{FF2B5EF4-FFF2-40B4-BE49-F238E27FC236}">
-                <a16:creationId xmlns:a16="http://schemas.microsoft.com/office/drawing/2014/main" id="{3D725FCE-1B96-6446-2D51-C7B38C6B1A15}"/>
-              </a:ext>
-            </a:extLst>
-          </p:cNvPr>
-          <p:cNvPicPr>
-            <a:picLocks noChangeAspect="1"/>
-          </p:cNvPicPr>
-          <p:nvPr/>
-        </p:nvPicPr>
-        <p:blipFill>
-          <a:blip r:embed="rId4"/>
-          <a:stretch>
-            <a:fillRect/>
-          </a:stretch>
-        </p:blipFill>
-        <p:spPr>
-          <a:xfrm>
-            <a:off x="5408866" y="4138652"/>
-            <a:ext cx="1702903" cy="1702903"/>
-          </a:xfrm>
-          <a:prstGeom prst="rect">
-            <a:avLst/>
-          </a:prstGeom>
-        </p:spPr>
-      </p:pic>
-      <p:pic>
-        <p:nvPicPr>
-          <p:cNvPr id="6" name="Imagem 5">
-            <a:extLst>
-              <a:ext uri="{FF2B5EF4-FFF2-40B4-BE49-F238E27FC236}">
-                <a16:creationId xmlns:a16="http://schemas.microsoft.com/office/drawing/2014/main" id="{51707BA7-450B-EAC9-FC4F-E51E703A31B9}"/>
-              </a:ext>
-            </a:extLst>
-          </p:cNvPr>
-          <p:cNvPicPr>
-            <a:picLocks noChangeAspect="1"/>
-          </p:cNvPicPr>
-          <p:nvPr/>
-        </p:nvPicPr>
-        <p:blipFill>
-          <a:blip r:embed="rId5"/>
-          <a:stretch>
-            <a:fillRect/>
-          </a:stretch>
-        </p:blipFill>
-        <p:spPr>
-          <a:xfrm>
-            <a:off x="10676689" y="3977111"/>
-            <a:ext cx="2025984" cy="2025984"/>
-          </a:xfrm>
-          <a:prstGeom prst="rect">
-            <a:avLst/>
-          </a:prstGeom>
-        </p:spPr>
-      </p:pic>
-    </p:spTree>
-    <p:extLst>
-      <p:ext uri="{BB962C8B-B14F-4D97-AF65-F5344CB8AC3E}">
-        <p14:creationId xmlns:p14="http://schemas.microsoft.com/office/powerpoint/2010/main" val="4250469377"/>
-      </p:ext>
-    </p:extLst>
-  </p:cSld>
-  <p:clrMapOvr>
-    <a:masterClrMapping/>
-  </p:clrMapOvr>
-</p:sld>
-</file>
-
-<file path=ppt/slides/slide5.xml><?xml version="1.0" encoding="utf-8"?>
-<p:sld xmlns:a="http://schemas.openxmlformats.org/drawingml/2006/main" xmlns:r="http://schemas.openxmlformats.org/officeDocument/2006/relationships" xmlns:p="http://schemas.openxmlformats.org/presentationml/2006/main">
-  <p:cSld>
-    <p:bg>
-      <p:bgPr>
-        <a:solidFill>
-          <a:srgbClr val="343F7F"/>
-        </a:solidFill>
-        <a:effectLst/>
-      </p:bgPr>
-    </p:bg>
-    <p:spTree>
-      <p:nvGrpSpPr>
-        <p:cNvPr id="1" name="Shape 93"/>
-        <p:cNvGrpSpPr/>
-        <p:nvPr/>
-      </p:nvGrpSpPr>
-      <p:grpSpPr>
-        <a:xfrm>
-          <a:off x="0" y="0"/>
-          <a:ext cx="0" cy="0"/>
-          <a:chOff x="0" y="0"/>
-          <a:chExt cx="0" cy="0"/>
-        </a:xfrm>
-      </p:grpSpPr>
-      <p:grpSp>
-        <p:nvGrpSpPr>
-          <p:cNvPr id="94" name="Google Shape;94;p14"/>
           <p:cNvGrpSpPr/>
           <p:nvPr/>
         </p:nvGrpSpPr>
         <p:grpSpPr>
           <a:xfrm>
-            <a:off x="498283" y="353622"/>
-            <a:ext cx="17291434" cy="9435095"/>
+            <a:off x="2354873" y="2982403"/>
+            <a:ext cx="14027997" cy="6027829"/>
             <a:chOff x="0" y="-38100"/>
-            <a:chExt cx="4554123" cy="2484963"/>
+            <a:chExt cx="3851033" cy="1654788"/>
           </a:xfrm>
         </p:grpSpPr>
         <p:sp>
           <p:nvSpPr>
-            <p:cNvPr id="95" name="Google Shape;95;p14"/>
+            <p:cNvPr id="480" name="Google Shape;480;p27">
+              <a:extLst>
+                <a:ext uri="{FF2B5EF4-FFF2-40B4-BE49-F238E27FC236}">
+                  <a16:creationId xmlns:a16="http://schemas.microsoft.com/office/drawing/2014/main" id="{C34BB61F-DFA9-2DA6-F520-1852C924D903}"/>
+                </a:ext>
+              </a:extLst>
+            </p:cNvPr>
             <p:cNvSpPr/>
             <p:nvPr/>
           </p:nvSpPr>
           <p:spPr>
             <a:xfrm>
               <a:off x="0" y="0"/>
-              <a:ext cx="4554122" cy="2446863"/>
+              <a:ext cx="3851033" cy="1616688"/>
             </a:xfrm>
             <a:custGeom>
               <a:avLst/>
@@ -13053,18 +11763,18 @@
               <a:cxnLst/>
               <a:rect l="l" t="t" r="r" b="b"/>
               <a:pathLst>
-                <a:path w="4554122" h="2446863" extrusionOk="0">
+                <a:path w="3851033" h="1616688" extrusionOk="0">
                   <a:moveTo>
                     <a:pt x="0" y="0"/>
                   </a:moveTo>
                   <a:lnTo>
-                    <a:pt x="4554122" y="0"/>
+                    <a:pt x="3851033" y="0"/>
                   </a:lnTo>
                   <a:lnTo>
-                    <a:pt x="4554122" y="2446863"/>
+                    <a:pt x="3851033" y="1616688"/>
                   </a:lnTo>
                   <a:lnTo>
-                    <a:pt x="0" y="2446863"/>
+                    <a:pt x="0" y="1616688"/>
                   </a:lnTo>
                   <a:close/>
                 </a:path>
@@ -13075,9 +11785,9 @@
                 <a:alpha val="0"/>
               </a:srgbClr>
             </a:solidFill>
-            <a:ln w="123825" cap="sq" cmpd="sng">
+            <a:ln w="152400" cap="sq" cmpd="sng">
               <a:solidFill>
-                <a:srgbClr val="BCFFB9"/>
+                <a:srgbClr val="FFF475"/>
               </a:solidFill>
               <a:prstDash val="solid"/>
               <a:miter lim="8000"/>
@@ -13095,14 +11805,20 @@
         </p:sp>
         <p:sp>
           <p:nvSpPr>
-            <p:cNvPr id="96" name="Google Shape;96;p14"/>
+            <p:cNvPr id="481" name="Google Shape;481;p27">
+              <a:extLst>
+                <a:ext uri="{FF2B5EF4-FFF2-40B4-BE49-F238E27FC236}">
+                  <a16:creationId xmlns:a16="http://schemas.microsoft.com/office/drawing/2014/main" id="{B9EF183D-25BC-41BD-CC60-04D36C853383}"/>
+                </a:ext>
+              </a:extLst>
+            </p:cNvPr>
             <p:cNvSpPr txBox="1"/>
             <p:nvPr/>
           </p:nvSpPr>
           <p:spPr>
             <a:xfrm>
               <a:off x="0" y="-38100"/>
-              <a:ext cx="4554123" cy="2484963"/>
+              <a:ext cx="3851033" cy="1654788"/>
             </a:xfrm>
             <a:prstGeom prst="rect">
               <a:avLst/>
@@ -13143,220 +11859,12 @@
           </p:txBody>
         </p:sp>
       </p:grpSp>
-      <p:pic>
-        <p:nvPicPr>
-          <p:cNvPr id="98" name="Google Shape;98;p14"/>
-          <p:cNvPicPr preferRelativeResize="0"/>
-          <p:nvPr/>
-        </p:nvPicPr>
-        <p:blipFill>
-          <a:blip r:embed="rId3">
-            <a:alphaModFix/>
-          </a:blip>
-          <a:stretch>
-            <a:fillRect/>
-          </a:stretch>
-        </p:blipFill>
-        <p:spPr>
-          <a:xfrm>
-            <a:off x="7503721" y="3380592"/>
-            <a:ext cx="3185775" cy="3185775"/>
-          </a:xfrm>
-          <a:prstGeom prst="rect">
-            <a:avLst/>
-          </a:prstGeom>
-          <a:noFill/>
-          <a:ln>
-            <a:noFill/>
-          </a:ln>
-        </p:spPr>
-      </p:pic>
-      <p:sp>
-        <p:nvSpPr>
-          <p:cNvPr id="100" name="Google Shape;100;p14"/>
-          <p:cNvSpPr txBox="1"/>
-          <p:nvPr/>
-        </p:nvSpPr>
-        <p:spPr>
-          <a:xfrm>
-            <a:off x="1697662" y="1096299"/>
-            <a:ext cx="14892600" cy="1702902"/>
-          </a:xfrm>
-          <a:prstGeom prst="rect">
-            <a:avLst/>
-          </a:prstGeom>
-          <a:noFill/>
-          <a:ln>
-            <a:noFill/>
-          </a:ln>
-        </p:spPr>
-        <p:txBody>
-          <a:bodyPr spcFirstLastPara="1" wrap="square" lIns="0" tIns="0" rIns="0" bIns="0" anchor="t" anchorCtr="0">
-            <a:spAutoFit/>
-          </a:bodyPr>
-          <a:lstStyle/>
-          <a:p>
-            <a:pPr marL="0" marR="0" lvl="0" indent="0" algn="ctr" rtl="0">
-              <a:lnSpc>
-                <a:spcPct val="110000"/>
-              </a:lnSpc>
-              <a:spcBef>
-                <a:spcPts val="0"/>
-              </a:spcBef>
-              <a:spcAft>
-                <a:spcPts val="0"/>
-              </a:spcAft>
-              <a:buNone/>
-            </a:pPr>
-            <a:r>
-              <a:rPr lang="en-US" sz="10060" b="1" i="0" u="none" strike="noStrike" cap="none" dirty="0">
-                <a:solidFill>
-                  <a:srgbClr val="BCFFB9"/>
-                </a:solidFill>
-                <a:latin typeface="League Spartan"/>
-                <a:ea typeface="League Spartan"/>
-                <a:cs typeface="League Spartan"/>
-                <a:sym typeface="League Spartan"/>
-              </a:rPr>
-              <a:t>BANCO DE DADOS</a:t>
-            </a:r>
-            <a:endParaRPr sz="3700" dirty="0"/>
-          </a:p>
-        </p:txBody>
-      </p:sp>
-      <p:sp>
-        <p:nvSpPr>
-          <p:cNvPr id="105" name="Google Shape;105;p14"/>
-          <p:cNvSpPr txBox="1"/>
-          <p:nvPr/>
-        </p:nvSpPr>
-        <p:spPr>
-          <a:xfrm>
-            <a:off x="5944084" y="6795865"/>
-            <a:ext cx="6399900" cy="639983"/>
-          </a:xfrm>
-          <a:prstGeom prst="rect">
-            <a:avLst/>
-          </a:prstGeom>
-          <a:noFill/>
-          <a:ln>
-            <a:noFill/>
-          </a:ln>
-        </p:spPr>
-        <p:txBody>
-          <a:bodyPr spcFirstLastPara="1" wrap="square" lIns="0" tIns="0" rIns="0" bIns="0" anchor="t" anchorCtr="0">
-            <a:spAutoFit/>
-          </a:bodyPr>
-          <a:lstStyle/>
-          <a:p>
-            <a:pPr marL="0" marR="0" lvl="0" indent="0" algn="ctr" rtl="0">
-              <a:lnSpc>
-                <a:spcPct val="130009"/>
-              </a:lnSpc>
-              <a:spcBef>
-                <a:spcPts val="0"/>
-              </a:spcBef>
-              <a:spcAft>
-                <a:spcPts val="0"/>
-              </a:spcAft>
-              <a:buNone/>
-            </a:pPr>
-            <a:r>
-              <a:rPr lang="en-US" sz="3199" b="1" i="0" u="none" strike="noStrike" cap="none" dirty="0">
-                <a:solidFill>
-                  <a:srgbClr val="FF779A"/>
-                </a:solidFill>
-                <a:latin typeface="Blinker"/>
-                <a:ea typeface="Blinker"/>
-                <a:cs typeface="Blinker"/>
-                <a:sym typeface="Blinker"/>
-              </a:rPr>
-              <a:t>SQL SERVER</a:t>
-            </a:r>
-            <a:endParaRPr dirty="0"/>
-          </a:p>
-        </p:txBody>
-      </p:sp>
-      <p:pic>
-        <p:nvPicPr>
-          <p:cNvPr id="4" name="Imagem 3">
+      <p:grpSp>
+        <p:nvGrpSpPr>
+          <p:cNvPr id="482" name="Google Shape;482;p27">
             <a:extLst>
               <a:ext uri="{FF2B5EF4-FFF2-40B4-BE49-F238E27FC236}">
-                <a16:creationId xmlns:a16="http://schemas.microsoft.com/office/drawing/2014/main" id="{FE68C1E3-3C88-DE23-260F-B8123CF64ED8}"/>
-              </a:ext>
-            </a:extLst>
-          </p:cNvPr>
-          <p:cNvPicPr>
-            <a:picLocks noChangeAspect="1"/>
-          </p:cNvPicPr>
-          <p:nvPr/>
-        </p:nvPicPr>
-        <p:blipFill>
-          <a:blip r:embed="rId4"/>
-          <a:stretch>
-            <a:fillRect/>
-          </a:stretch>
-        </p:blipFill>
-        <p:spPr>
-          <a:xfrm>
-            <a:off x="8254360" y="4077836"/>
-            <a:ext cx="1779280" cy="1779280"/>
-          </a:xfrm>
-          <a:prstGeom prst="rect">
-            <a:avLst/>
-          </a:prstGeom>
-        </p:spPr>
-      </p:pic>
-    </p:spTree>
-    <p:extLst>
-      <p:ext uri="{BB962C8B-B14F-4D97-AF65-F5344CB8AC3E}">
-        <p14:creationId xmlns:p14="http://schemas.microsoft.com/office/powerpoint/2010/main" val="2116844047"/>
-      </p:ext>
-    </p:extLst>
-  </p:cSld>
-  <p:clrMapOvr>
-    <a:masterClrMapping/>
-  </p:clrMapOvr>
-</p:sld>
-</file>
-
-<file path=ppt/slides/slide6.xml><?xml version="1.0" encoding="utf-8"?>
-<p:sld xmlns:a="http://schemas.openxmlformats.org/drawingml/2006/main" xmlns:r="http://schemas.openxmlformats.org/officeDocument/2006/relationships" xmlns:p="http://schemas.openxmlformats.org/presentationml/2006/main">
-  <p:cSld>
-    <p:bg>
-      <p:bgPr>
-        <a:solidFill>
-          <a:srgbClr val="343F7F"/>
-        </a:solidFill>
-        <a:effectLst/>
-      </p:bgPr>
-    </p:bg>
-    <p:spTree>
-      <p:nvGrpSpPr>
-        <p:cNvPr id="1" name="Shape 93">
-          <a:extLst>
-            <a:ext uri="{FF2B5EF4-FFF2-40B4-BE49-F238E27FC236}">
-              <a16:creationId xmlns:a16="http://schemas.microsoft.com/office/drawing/2014/main" id="{E0C859B9-DF64-CD21-696E-4CFF26187255}"/>
-            </a:ext>
-          </a:extLst>
-        </p:cNvPr>
-        <p:cNvGrpSpPr/>
-        <p:nvPr/>
-      </p:nvGrpSpPr>
-      <p:grpSpPr>
-        <a:xfrm>
-          <a:off x="0" y="0"/>
-          <a:ext cx="0" cy="0"/>
-          <a:chOff x="0" y="0"/>
-          <a:chExt cx="0" cy="0"/>
-        </a:xfrm>
-      </p:grpSpPr>
-      <p:grpSp>
-        <p:nvGrpSpPr>
-          <p:cNvPr id="94" name="Google Shape;94;p14">
-            <a:extLst>
-              <a:ext uri="{FF2B5EF4-FFF2-40B4-BE49-F238E27FC236}">
-                <a16:creationId xmlns:a16="http://schemas.microsoft.com/office/drawing/2014/main" id="{7D81A281-B220-D97A-9FE4-43A449573C57}"/>
+                <a16:creationId xmlns:a16="http://schemas.microsoft.com/office/drawing/2014/main" id="{40A29916-A41B-AC13-BE4A-FF83F0AA92D2}"/>
               </a:ext>
             </a:extLst>
           </p:cNvPr>
@@ -13365,18 +11873,18 @@
         </p:nvGrpSpPr>
         <p:grpSpPr>
           <a:xfrm>
-            <a:off x="498283" y="353622"/>
-            <a:ext cx="17291434" cy="9435095"/>
+            <a:off x="1728761" y="2495252"/>
+            <a:ext cx="14027997" cy="6027829"/>
             <a:chOff x="0" y="-38100"/>
-            <a:chExt cx="4554123" cy="2484963"/>
+            <a:chExt cx="3851033" cy="1654788"/>
           </a:xfrm>
         </p:grpSpPr>
         <p:sp>
           <p:nvSpPr>
-            <p:cNvPr id="95" name="Google Shape;95;p14">
+            <p:cNvPr id="483" name="Google Shape;483;p27">
               <a:extLst>
                 <a:ext uri="{FF2B5EF4-FFF2-40B4-BE49-F238E27FC236}">
-                  <a16:creationId xmlns:a16="http://schemas.microsoft.com/office/drawing/2014/main" id="{4E116638-34BA-E0AA-AD57-3DEA16D00656}"/>
+                  <a16:creationId xmlns:a16="http://schemas.microsoft.com/office/drawing/2014/main" id="{B5AD9938-5236-4FB3-FC3A-1A80F6C51129}"/>
                 </a:ext>
               </a:extLst>
             </p:cNvPr>
@@ -13386,7 +11894,7 @@
           <p:spPr>
             <a:xfrm>
               <a:off x="0" y="0"/>
-              <a:ext cx="4554122" cy="2446863"/>
+              <a:ext cx="3851033" cy="1616688"/>
             </a:xfrm>
             <a:custGeom>
               <a:avLst/>
@@ -13395,36 +11903,28 @@
               <a:cxnLst/>
               <a:rect l="l" t="t" r="r" b="b"/>
               <a:pathLst>
-                <a:path w="4554122" h="2446863" extrusionOk="0">
+                <a:path w="3851033" h="1616688" extrusionOk="0">
                   <a:moveTo>
                     <a:pt x="0" y="0"/>
                   </a:moveTo>
                   <a:lnTo>
-                    <a:pt x="4554122" y="0"/>
+                    <a:pt x="3851033" y="0"/>
                   </a:lnTo>
                   <a:lnTo>
-                    <a:pt x="4554122" y="2446863"/>
+                    <a:pt x="3851033" y="1616688"/>
                   </a:lnTo>
                   <a:lnTo>
-                    <a:pt x="0" y="2446863"/>
+                    <a:pt x="0" y="1616688"/>
                   </a:lnTo>
                   <a:close/>
                 </a:path>
               </a:pathLst>
             </a:custGeom>
             <a:solidFill>
-              <a:srgbClr val="000000">
-                <a:alpha val="0"/>
-              </a:srgbClr>
+              <a:srgbClr val="92E4EB"/>
             </a:solidFill>
-            <a:ln w="123825" cap="sq" cmpd="sng">
-              <a:solidFill>
-                <a:srgbClr val="BCFFB9"/>
-              </a:solidFill>
-              <a:prstDash val="solid"/>
-              <a:miter lim="8000"/>
-              <a:headEnd type="none" w="sm" len="sm"/>
-              <a:tailEnd type="none" w="sm" len="sm"/>
+            <a:ln>
+              <a:noFill/>
             </a:ln>
           </p:spPr>
           <p:txBody>
@@ -13437,10 +11937,10 @@
         </p:sp>
         <p:sp>
           <p:nvSpPr>
-            <p:cNvPr id="96" name="Google Shape;96;p14">
+            <p:cNvPr id="484" name="Google Shape;484;p27">
               <a:extLst>
                 <a:ext uri="{FF2B5EF4-FFF2-40B4-BE49-F238E27FC236}">
-                  <a16:creationId xmlns:a16="http://schemas.microsoft.com/office/drawing/2014/main" id="{F8FD511D-33A1-DC91-B8E4-7A69D9899E56}"/>
+                  <a16:creationId xmlns:a16="http://schemas.microsoft.com/office/drawing/2014/main" id="{59A16F88-6E63-2DB0-AE0B-000C31C1A083}"/>
                 </a:ext>
               </a:extLst>
             </p:cNvPr>
@@ -13450,7 +11950,7 @@
           <p:spPr>
             <a:xfrm>
               <a:off x="0" y="-38100"/>
-              <a:ext cx="4554123" cy="2484963"/>
+              <a:ext cx="3851033" cy="1654788"/>
             </a:xfrm>
             <a:prstGeom prst="rect">
               <a:avLst/>
@@ -13491,46 +11991,1379 @@
           </p:txBody>
         </p:sp>
       </p:grpSp>
-      <p:pic>
-        <p:nvPicPr>
-          <p:cNvPr id="98" name="Google Shape;98;p14">
+      <p:graphicFrame>
+        <p:nvGraphicFramePr>
+          <p:cNvPr id="485" name="Google Shape;485;p27">
             <a:extLst>
               <a:ext uri="{FF2B5EF4-FFF2-40B4-BE49-F238E27FC236}">
-                <a16:creationId xmlns:a16="http://schemas.microsoft.com/office/drawing/2014/main" id="{0D602582-4D52-63E9-7F26-30A0A25D9007}"/>
+                <a16:creationId xmlns:a16="http://schemas.microsoft.com/office/drawing/2014/main" id="{786938B6-625A-D67A-C441-A82DBDBFE5A6}"/>
               </a:ext>
             </a:extLst>
           </p:cNvPr>
-          <p:cNvPicPr preferRelativeResize="0"/>
-          <p:nvPr/>
-        </p:nvPicPr>
-        <p:blipFill>
-          <a:blip r:embed="rId3">
-            <a:alphaModFix/>
-          </a:blip>
-          <a:stretch>
-            <a:fillRect/>
-          </a:stretch>
-        </p:blipFill>
-        <p:spPr>
-          <a:xfrm>
-            <a:off x="7503721" y="3380592"/>
-            <a:ext cx="3185775" cy="3185775"/>
-          </a:xfrm>
-          <a:prstGeom prst="rect">
-            <a:avLst/>
-          </a:prstGeom>
-          <a:noFill/>
-          <a:ln>
-            <a:noFill/>
-          </a:ln>
-        </p:spPr>
-      </p:pic>
+          <p:cNvGraphicFramePr/>
+          <p:nvPr>
+            <p:extLst>
+              <p:ext uri="{D42A27DB-BD31-4B8C-83A1-F6EECF244321}">
+                <p14:modId xmlns:p14="http://schemas.microsoft.com/office/powerpoint/2010/main" val="3674871095"/>
+              </p:ext>
+            </p:extLst>
+          </p:nvPr>
+        </p:nvGraphicFramePr>
+        <p:xfrm>
+          <a:off x="1911927" y="2787168"/>
+          <a:ext cx="14151315" cy="5867999"/>
+        </p:xfrm>
+        <a:graphic>
+          <a:graphicData uri="http://schemas.openxmlformats.org/drawingml/2006/table">
+            <a:tbl>
+              <a:tblPr>
+                <a:noFill/>
+                <a:tableStyleId>{89A0B9CA-3001-4300-81F6-6C451510DCC4}</a:tableStyleId>
+              </a:tblPr>
+              <a:tblGrid>
+                <a:gridCol w="2234365">
+                  <a:extLst>
+                    <a:ext uri="{9D8B030D-6E8A-4147-A177-3AD203B41FA5}">
+                      <a16:colId xmlns:a16="http://schemas.microsoft.com/office/drawing/2014/main" val="20000"/>
+                    </a:ext>
+                  </a:extLst>
+                </a:gridCol>
+                <a:gridCol w="4596000">
+                  <a:extLst>
+                    <a:ext uri="{9D8B030D-6E8A-4147-A177-3AD203B41FA5}">
+                      <a16:colId xmlns:a16="http://schemas.microsoft.com/office/drawing/2014/main" val="20001"/>
+                    </a:ext>
+                  </a:extLst>
+                </a:gridCol>
+                <a:gridCol w="3660475">
+                  <a:extLst>
+                    <a:ext uri="{9D8B030D-6E8A-4147-A177-3AD203B41FA5}">
+                      <a16:colId xmlns:a16="http://schemas.microsoft.com/office/drawing/2014/main" val="20002"/>
+                    </a:ext>
+                  </a:extLst>
+                </a:gridCol>
+                <a:gridCol w="3660475">
+                  <a:extLst>
+                    <a:ext uri="{9D8B030D-6E8A-4147-A177-3AD203B41FA5}">
+                      <a16:colId xmlns:a16="http://schemas.microsoft.com/office/drawing/2014/main" val="20003"/>
+                    </a:ext>
+                  </a:extLst>
+                </a:gridCol>
+              </a:tblGrid>
+              <a:tr h="1447500">
+                <a:tc>
+                  <a:txBody>
+                    <a:bodyPr/>
+                    <a:lstStyle/>
+                    <a:p>
+                      <a:pPr marL="0" marR="0" lvl="0" indent="0" algn="ctr" rtl="0">
+                        <a:lnSpc>
+                          <a:spcPct val="139962"/>
+                        </a:lnSpc>
+                        <a:spcBef>
+                          <a:spcPts val="0"/>
+                        </a:spcBef>
+                        <a:spcAft>
+                          <a:spcPts val="0"/>
+                        </a:spcAft>
+                        <a:buNone/>
+                      </a:pPr>
+                      <a:r>
+                        <a:rPr lang="en-US" sz="2700" b="1" u="none" strike="noStrike" cap="none" dirty="0">
+                          <a:solidFill>
+                            <a:srgbClr val="FFFFFF"/>
+                          </a:solidFill>
+                          <a:latin typeface="Blinker"/>
+                          <a:ea typeface="Blinker"/>
+                          <a:cs typeface="Blinker"/>
+                          <a:sym typeface="Blinker"/>
+                        </a:rPr>
+                        <a:t>FRONT-END</a:t>
+                      </a:r>
+                      <a:endParaRPr sz="1100" u="none" strike="noStrike" cap="none" dirty="0"/>
+                    </a:p>
+                  </a:txBody>
+                  <a:tcPr marL="182775" marR="182775" marT="182775" marB="182775" anchor="ctr">
+                    <a:lnL w="9525" cap="flat" cmpd="sng">
+                      <a:solidFill>
+                        <a:srgbClr val="FFFFFF">
+                          <a:alpha val="0"/>
+                        </a:srgbClr>
+                      </a:solidFill>
+                      <a:prstDash val="solid"/>
+                      <a:round/>
+                      <a:headEnd type="none" w="sm" len="sm"/>
+                      <a:tailEnd type="none" w="sm" len="sm"/>
+                    </a:lnL>
+                    <a:lnR w="9525" cap="flat" cmpd="sng" algn="ctr">
+                      <a:solidFill>
+                        <a:srgbClr val="FFFFFF">
+                          <a:alpha val="0"/>
+                        </a:srgbClr>
+                      </a:solidFill>
+                      <a:prstDash val="solid"/>
+                      <a:round/>
+                      <a:headEnd type="none" w="sm" len="sm"/>
+                      <a:tailEnd type="none" w="sm" len="sm"/>
+                    </a:lnR>
+                    <a:lnT w="38100" cap="flat" cmpd="sng">
+                      <a:solidFill>
+                        <a:schemeClr val="lt1"/>
+                      </a:solidFill>
+                      <a:prstDash val="solid"/>
+                      <a:round/>
+                      <a:headEnd type="none" w="sm" len="sm"/>
+                      <a:tailEnd type="none" w="sm" len="sm"/>
+                    </a:lnT>
+                    <a:lnB w="38100" cap="flat" cmpd="sng">
+                      <a:solidFill>
+                        <a:schemeClr val="lt1"/>
+                      </a:solidFill>
+                      <a:prstDash val="solid"/>
+                      <a:round/>
+                      <a:headEnd type="none" w="sm" len="sm"/>
+                      <a:tailEnd type="none" w="sm" len="sm"/>
+                    </a:lnB>
+                    <a:solidFill>
+                      <a:srgbClr val="CE8FFF"/>
+                    </a:solidFill>
+                  </a:tcPr>
+                </a:tc>
+                <a:tc>
+                  <a:txBody>
+                    <a:bodyPr/>
+                    <a:lstStyle/>
+                    <a:p>
+                      <a:pPr marL="0" marR="0" lvl="0" indent="0" algn="ctr" rtl="0">
+                        <a:lnSpc>
+                          <a:spcPct val="140000"/>
+                        </a:lnSpc>
+                        <a:spcBef>
+                          <a:spcPts val="0"/>
+                        </a:spcBef>
+                        <a:spcAft>
+                          <a:spcPts val="0"/>
+                        </a:spcAft>
+                        <a:buNone/>
+                      </a:pPr>
+                      <a:r>
+                        <a:rPr lang="en-US" sz="3545" u="none" strike="noStrike" cap="none" dirty="0">
+                          <a:solidFill>
+                            <a:srgbClr val="FFFFFF"/>
+                          </a:solidFill>
+                          <a:latin typeface="League Spartan"/>
+                          <a:ea typeface="League Spartan"/>
+                          <a:cs typeface="League Spartan"/>
+                          <a:sym typeface="League Spartan"/>
+                        </a:rPr>
+                        <a:t>ANGULAR</a:t>
+                      </a:r>
+                      <a:endParaRPr sz="1100" u="none" strike="noStrike" cap="none" dirty="0"/>
+                    </a:p>
+                  </a:txBody>
+                  <a:tcPr marL="182775" marR="182775" marT="182775" marB="182775" anchor="ctr">
+                    <a:lnL w="9525" cap="flat" cmpd="sng" algn="ctr">
+                      <a:solidFill>
+                        <a:srgbClr val="FFFFFF">
+                          <a:alpha val="0"/>
+                        </a:srgbClr>
+                      </a:solidFill>
+                      <a:prstDash val="solid"/>
+                      <a:round/>
+                      <a:headEnd type="none" w="sm" len="sm"/>
+                      <a:tailEnd type="none" w="sm" len="sm"/>
+                    </a:lnL>
+                    <a:lnR w="9525" cap="flat" cmpd="sng" algn="ctr">
+                      <a:solidFill>
+                        <a:srgbClr val="FFFFFF">
+                          <a:alpha val="0"/>
+                        </a:srgbClr>
+                      </a:solidFill>
+                      <a:prstDash val="solid"/>
+                      <a:round/>
+                      <a:headEnd type="none" w="sm" len="sm"/>
+                      <a:tailEnd type="none" w="sm" len="sm"/>
+                    </a:lnR>
+                    <a:lnT w="38100" cap="flat" cmpd="sng">
+                      <a:solidFill>
+                        <a:schemeClr val="lt1"/>
+                      </a:solidFill>
+                      <a:prstDash val="solid"/>
+                      <a:round/>
+                      <a:headEnd type="none" w="sm" len="sm"/>
+                      <a:tailEnd type="none" w="sm" len="sm"/>
+                    </a:lnT>
+                    <a:lnB w="38100" cap="flat" cmpd="sng">
+                      <a:solidFill>
+                        <a:schemeClr val="lt1"/>
+                      </a:solidFill>
+                      <a:prstDash val="solid"/>
+                      <a:round/>
+                      <a:headEnd type="none" w="sm" len="sm"/>
+                      <a:tailEnd type="none" w="sm" len="sm"/>
+                    </a:lnB>
+                    <a:solidFill>
+                      <a:srgbClr val="CE8FFF"/>
+                    </a:solidFill>
+                  </a:tcPr>
+                </a:tc>
+                <a:tc>
+                  <a:txBody>
+                    <a:bodyPr/>
+                    <a:lstStyle/>
+                    <a:p>
+                      <a:pPr marL="0" marR="0" lvl="0" indent="0" algn="ctr" rtl="0">
+                        <a:lnSpc>
+                          <a:spcPct val="140000"/>
+                        </a:lnSpc>
+                        <a:spcBef>
+                          <a:spcPts val="0"/>
+                        </a:spcBef>
+                        <a:spcAft>
+                          <a:spcPts val="0"/>
+                        </a:spcAft>
+                        <a:buNone/>
+                      </a:pPr>
+                      <a:r>
+                        <a:rPr lang="en-US" sz="3545" u="none" strike="noStrike" cap="none" dirty="0">
+                          <a:solidFill>
+                            <a:srgbClr val="FFFFFF"/>
+                          </a:solidFill>
+                          <a:latin typeface="League Spartan"/>
+                          <a:ea typeface="League Spartan"/>
+                          <a:cs typeface="League Spartan"/>
+                          <a:sym typeface="League Spartan"/>
+                        </a:rPr>
+                        <a:t>TYPESCRIPT</a:t>
+                      </a:r>
+                      <a:endParaRPr sz="1100" u="none" strike="noStrike" cap="none" dirty="0"/>
+                    </a:p>
+                  </a:txBody>
+                  <a:tcPr marL="182775" marR="182775" marT="182775" marB="182775" anchor="ctr">
+                    <a:lnL w="9525" cap="flat" cmpd="sng" algn="ctr">
+                      <a:solidFill>
+                        <a:srgbClr val="FFFFFF">
+                          <a:alpha val="0"/>
+                        </a:srgbClr>
+                      </a:solidFill>
+                      <a:prstDash val="solid"/>
+                      <a:round/>
+                      <a:headEnd type="none" w="sm" len="sm"/>
+                      <a:tailEnd type="none" w="sm" len="sm"/>
+                    </a:lnL>
+                    <a:lnR w="9525" cap="flat" cmpd="sng" algn="ctr">
+                      <a:solidFill>
+                        <a:srgbClr val="FFFFFF">
+                          <a:alpha val="0"/>
+                        </a:srgbClr>
+                      </a:solidFill>
+                      <a:prstDash val="solid"/>
+                      <a:round/>
+                      <a:headEnd type="none" w="sm" len="sm"/>
+                      <a:tailEnd type="none" w="sm" len="sm"/>
+                    </a:lnR>
+                    <a:lnT w="38100" cap="flat" cmpd="sng">
+                      <a:solidFill>
+                        <a:schemeClr val="lt1"/>
+                      </a:solidFill>
+                      <a:prstDash val="solid"/>
+                      <a:round/>
+                      <a:headEnd type="none" w="sm" len="sm"/>
+                      <a:tailEnd type="none" w="sm" len="sm"/>
+                    </a:lnT>
+                    <a:lnB w="38100" cap="flat" cmpd="sng">
+                      <a:solidFill>
+                        <a:schemeClr val="lt1"/>
+                      </a:solidFill>
+                      <a:prstDash val="solid"/>
+                      <a:round/>
+                      <a:headEnd type="none" w="sm" len="sm"/>
+                      <a:tailEnd type="none" w="sm" len="sm"/>
+                    </a:lnB>
+                    <a:solidFill>
+                      <a:srgbClr val="CE8FFF"/>
+                    </a:solidFill>
+                  </a:tcPr>
+                </a:tc>
+                <a:tc>
+                  <a:txBody>
+                    <a:bodyPr/>
+                    <a:lstStyle/>
+                    <a:p>
+                      <a:pPr marL="0" marR="0" lvl="0" indent="0" algn="ctr" rtl="0">
+                        <a:lnSpc>
+                          <a:spcPct val="140000"/>
+                        </a:lnSpc>
+                        <a:spcBef>
+                          <a:spcPts val="0"/>
+                        </a:spcBef>
+                        <a:spcAft>
+                          <a:spcPts val="0"/>
+                        </a:spcAft>
+                        <a:buNone/>
+                      </a:pPr>
+                      <a:r>
+                        <a:rPr lang="en-US" sz="3545" u="none" strike="noStrike" cap="none" dirty="0">
+                          <a:solidFill>
+                            <a:srgbClr val="FFFFFF"/>
+                          </a:solidFill>
+                          <a:latin typeface="League Spartan"/>
+                          <a:ea typeface="League Spartan"/>
+                          <a:cs typeface="League Spartan"/>
+                          <a:sym typeface="League Spartan"/>
+                        </a:rPr>
+                        <a:t>TAILWIND</a:t>
+                      </a:r>
+                      <a:endParaRPr sz="1100" u="none" strike="noStrike" cap="none" dirty="0"/>
+                    </a:p>
+                  </a:txBody>
+                  <a:tcPr marL="182775" marR="182775" marT="182775" marB="182775" anchor="ctr">
+                    <a:lnL w="9525" cap="flat" cmpd="sng" algn="ctr">
+                      <a:solidFill>
+                        <a:srgbClr val="FFFFFF">
+                          <a:alpha val="0"/>
+                        </a:srgbClr>
+                      </a:solidFill>
+                      <a:prstDash val="solid"/>
+                      <a:round/>
+                      <a:headEnd type="none" w="sm" len="sm"/>
+                      <a:tailEnd type="none" w="sm" len="sm"/>
+                    </a:lnL>
+                    <a:lnR w="9525" cap="flat" cmpd="sng">
+                      <a:solidFill>
+                        <a:srgbClr val="FFFFFF">
+                          <a:alpha val="0"/>
+                        </a:srgbClr>
+                      </a:solidFill>
+                      <a:prstDash val="solid"/>
+                      <a:round/>
+                      <a:headEnd type="none" w="sm" len="sm"/>
+                      <a:tailEnd type="none" w="sm" len="sm"/>
+                    </a:lnR>
+                    <a:lnT w="38100" cap="flat" cmpd="sng">
+                      <a:solidFill>
+                        <a:schemeClr val="lt1"/>
+                      </a:solidFill>
+                      <a:prstDash val="solid"/>
+                      <a:round/>
+                      <a:headEnd type="none" w="sm" len="sm"/>
+                      <a:tailEnd type="none" w="sm" len="sm"/>
+                    </a:lnT>
+                    <a:lnB w="38100" cap="flat" cmpd="sng">
+                      <a:solidFill>
+                        <a:schemeClr val="lt1"/>
+                      </a:solidFill>
+                      <a:prstDash val="solid"/>
+                      <a:round/>
+                      <a:headEnd type="none" w="sm" len="sm"/>
+                      <a:tailEnd type="none" w="sm" len="sm"/>
+                    </a:lnB>
+                    <a:solidFill>
+                      <a:srgbClr val="CE8FFF"/>
+                    </a:solidFill>
+                  </a:tcPr>
+                </a:tc>
+                <a:extLst>
+                  <a:ext uri="{0D108BD9-81ED-4DB2-BD59-A6C34878D82A}">
+                    <a16:rowId xmlns:a16="http://schemas.microsoft.com/office/drawing/2014/main" val="10001"/>
+                  </a:ext>
+                </a:extLst>
+              </a:tr>
+              <a:tr h="1447500">
+                <a:tc>
+                  <a:txBody>
+                    <a:bodyPr/>
+                    <a:lstStyle/>
+                    <a:p>
+                      <a:pPr marL="0" marR="0" lvl="0" indent="0" algn="ctr" rtl="0">
+                        <a:lnSpc>
+                          <a:spcPct val="139962"/>
+                        </a:lnSpc>
+                        <a:spcBef>
+                          <a:spcPts val="0"/>
+                        </a:spcBef>
+                        <a:spcAft>
+                          <a:spcPts val="0"/>
+                        </a:spcAft>
+                        <a:buNone/>
+                      </a:pPr>
+                      <a:r>
+                        <a:rPr lang="en-US" sz="2700" b="1" u="none" strike="noStrike" cap="none" dirty="0">
+                          <a:solidFill>
+                            <a:srgbClr val="FFFFFF"/>
+                          </a:solidFill>
+                          <a:latin typeface="Blinker"/>
+                          <a:ea typeface="Blinker"/>
+                          <a:cs typeface="Blinker"/>
+                          <a:sym typeface="Blinker"/>
+                        </a:rPr>
+                        <a:t>BACK-END</a:t>
+                      </a:r>
+                      <a:endParaRPr sz="1100" u="none" strike="noStrike" cap="none" dirty="0"/>
+                    </a:p>
+                  </a:txBody>
+                  <a:tcPr marL="182775" marR="182775" marT="182775" marB="182775" anchor="ctr">
+                    <a:lnL w="9525" cap="flat" cmpd="sng">
+                      <a:solidFill>
+                        <a:srgbClr val="FFFFFF">
+                          <a:alpha val="0"/>
+                        </a:srgbClr>
+                      </a:solidFill>
+                      <a:prstDash val="solid"/>
+                      <a:round/>
+                      <a:headEnd type="none" w="sm" len="sm"/>
+                      <a:tailEnd type="none" w="sm" len="sm"/>
+                    </a:lnL>
+                    <a:lnR w="9525" cap="flat" cmpd="sng">
+                      <a:solidFill>
+                        <a:srgbClr val="FFFFFF">
+                          <a:alpha val="0"/>
+                        </a:srgbClr>
+                      </a:solidFill>
+                      <a:prstDash val="solid"/>
+                      <a:round/>
+                      <a:headEnd type="none" w="sm" len="sm"/>
+                      <a:tailEnd type="none" w="sm" len="sm"/>
+                    </a:lnR>
+                    <a:lnT w="38100" cap="flat" cmpd="sng">
+                      <a:solidFill>
+                        <a:schemeClr val="lt1"/>
+                      </a:solidFill>
+                      <a:prstDash val="solid"/>
+                      <a:round/>
+                      <a:headEnd type="none" w="sm" len="sm"/>
+                      <a:tailEnd type="none" w="sm" len="sm"/>
+                    </a:lnT>
+                    <a:lnB w="38100" cap="flat" cmpd="sng">
+                      <a:solidFill>
+                        <a:schemeClr val="lt1"/>
+                      </a:solidFill>
+                      <a:prstDash val="solid"/>
+                      <a:round/>
+                      <a:headEnd type="none" w="sm" len="sm"/>
+                      <a:tailEnd type="none" w="sm" len="sm"/>
+                    </a:lnB>
+                    <a:solidFill>
+                      <a:srgbClr val="FF779A"/>
+                    </a:solidFill>
+                  </a:tcPr>
+                </a:tc>
+                <a:tc>
+                  <a:txBody>
+                    <a:bodyPr/>
+                    <a:lstStyle/>
+                    <a:p>
+                      <a:pPr marL="0" marR="0" lvl="0" indent="0" algn="ctr" rtl="0">
+                        <a:lnSpc>
+                          <a:spcPct val="140000"/>
+                        </a:lnSpc>
+                        <a:spcBef>
+                          <a:spcPts val="0"/>
+                        </a:spcBef>
+                        <a:spcAft>
+                          <a:spcPts val="0"/>
+                        </a:spcAft>
+                        <a:buNone/>
+                      </a:pPr>
+                      <a:r>
+                        <a:rPr lang="en-US" sz="3545" u="none" strike="noStrike" cap="none" dirty="0">
+                          <a:solidFill>
+                            <a:srgbClr val="FFFFFF"/>
+                          </a:solidFill>
+                          <a:latin typeface="League Spartan"/>
+                          <a:ea typeface="League Spartan"/>
+                          <a:cs typeface="League Spartan"/>
+                          <a:sym typeface="League Spartan"/>
+                        </a:rPr>
+                        <a:t>C#</a:t>
+                      </a:r>
+                      <a:endParaRPr sz="1100" u="none" strike="noStrike" cap="none" dirty="0"/>
+                    </a:p>
+                  </a:txBody>
+                  <a:tcPr marL="182775" marR="182775" marT="182775" marB="182775" anchor="ctr">
+                    <a:lnL w="9525" cap="flat" cmpd="sng">
+                      <a:solidFill>
+                        <a:srgbClr val="FFFFFF">
+                          <a:alpha val="0"/>
+                        </a:srgbClr>
+                      </a:solidFill>
+                      <a:prstDash val="solid"/>
+                      <a:round/>
+                      <a:headEnd type="none" w="sm" len="sm"/>
+                      <a:tailEnd type="none" w="sm" len="sm"/>
+                    </a:lnL>
+                    <a:lnR w="9525" cap="flat" cmpd="sng">
+                      <a:solidFill>
+                        <a:srgbClr val="FFFFFF">
+                          <a:alpha val="0"/>
+                        </a:srgbClr>
+                      </a:solidFill>
+                      <a:prstDash val="solid"/>
+                      <a:round/>
+                      <a:headEnd type="none" w="sm" len="sm"/>
+                      <a:tailEnd type="none" w="sm" len="sm"/>
+                    </a:lnR>
+                    <a:lnT w="38100" cap="flat" cmpd="sng">
+                      <a:solidFill>
+                        <a:schemeClr val="lt1"/>
+                      </a:solidFill>
+                      <a:prstDash val="solid"/>
+                      <a:round/>
+                      <a:headEnd type="none" w="sm" len="sm"/>
+                      <a:tailEnd type="none" w="sm" len="sm"/>
+                    </a:lnT>
+                    <a:lnB w="38100" cap="flat" cmpd="sng">
+                      <a:solidFill>
+                        <a:schemeClr val="lt1"/>
+                      </a:solidFill>
+                      <a:prstDash val="solid"/>
+                      <a:round/>
+                      <a:headEnd type="none" w="sm" len="sm"/>
+                      <a:tailEnd type="none" w="sm" len="sm"/>
+                    </a:lnB>
+                    <a:solidFill>
+                      <a:srgbClr val="FF779A"/>
+                    </a:solidFill>
+                  </a:tcPr>
+                </a:tc>
+                <a:tc>
+                  <a:txBody>
+                    <a:bodyPr/>
+                    <a:lstStyle/>
+                    <a:p>
+                      <a:pPr marL="0" marR="0" lvl="0" indent="0" algn="ctr" rtl="0">
+                        <a:lnSpc>
+                          <a:spcPct val="140000"/>
+                        </a:lnSpc>
+                        <a:spcBef>
+                          <a:spcPts val="0"/>
+                        </a:spcBef>
+                        <a:spcAft>
+                          <a:spcPts val="0"/>
+                        </a:spcAft>
+                        <a:buNone/>
+                      </a:pPr>
+                      <a:r>
+                        <a:rPr lang="en-US" sz="3545" u="none" strike="noStrike" cap="none" dirty="0">
+                          <a:solidFill>
+                            <a:srgbClr val="FFFFFF"/>
+                          </a:solidFill>
+                          <a:latin typeface="League Spartan"/>
+                          <a:ea typeface="League Spartan"/>
+                          <a:cs typeface="League Spartan"/>
+                          <a:sym typeface="League Spartan"/>
+                        </a:rPr>
+                        <a:t>.NET</a:t>
+                      </a:r>
+                      <a:endParaRPr sz="1100" u="none" strike="noStrike" cap="none" dirty="0"/>
+                    </a:p>
+                  </a:txBody>
+                  <a:tcPr marL="182775" marR="182775" marT="182775" marB="182775" anchor="ctr">
+                    <a:lnL w="9525" cap="flat" cmpd="sng">
+                      <a:solidFill>
+                        <a:srgbClr val="FFFFFF">
+                          <a:alpha val="0"/>
+                        </a:srgbClr>
+                      </a:solidFill>
+                      <a:prstDash val="solid"/>
+                      <a:round/>
+                      <a:headEnd type="none" w="sm" len="sm"/>
+                      <a:tailEnd type="none" w="sm" len="sm"/>
+                    </a:lnL>
+                    <a:lnR w="9525" cap="flat" cmpd="sng">
+                      <a:solidFill>
+                        <a:srgbClr val="FFFFFF">
+                          <a:alpha val="0"/>
+                        </a:srgbClr>
+                      </a:solidFill>
+                      <a:prstDash val="solid"/>
+                      <a:round/>
+                      <a:headEnd type="none" w="sm" len="sm"/>
+                      <a:tailEnd type="none" w="sm" len="sm"/>
+                    </a:lnR>
+                    <a:lnT w="38100" cap="flat" cmpd="sng">
+                      <a:solidFill>
+                        <a:schemeClr val="lt1"/>
+                      </a:solidFill>
+                      <a:prstDash val="solid"/>
+                      <a:round/>
+                      <a:headEnd type="none" w="sm" len="sm"/>
+                      <a:tailEnd type="none" w="sm" len="sm"/>
+                    </a:lnT>
+                    <a:lnB w="38100" cap="flat" cmpd="sng">
+                      <a:solidFill>
+                        <a:schemeClr val="lt1"/>
+                      </a:solidFill>
+                      <a:prstDash val="solid"/>
+                      <a:round/>
+                      <a:headEnd type="none" w="sm" len="sm"/>
+                      <a:tailEnd type="none" w="sm" len="sm"/>
+                    </a:lnB>
+                    <a:solidFill>
+                      <a:srgbClr val="FF779A"/>
+                    </a:solidFill>
+                  </a:tcPr>
+                </a:tc>
+                <a:tc>
+                  <a:txBody>
+                    <a:bodyPr/>
+                    <a:lstStyle/>
+                    <a:p>
+                      <a:pPr marL="0" marR="0" lvl="0" indent="0" algn="ctr" rtl="0">
+                        <a:lnSpc>
+                          <a:spcPct val="140000"/>
+                        </a:lnSpc>
+                        <a:spcBef>
+                          <a:spcPts val="0"/>
+                        </a:spcBef>
+                        <a:spcAft>
+                          <a:spcPts val="0"/>
+                        </a:spcAft>
+                        <a:buNone/>
+                      </a:pPr>
+                      <a:endParaRPr sz="1100" u="none" strike="noStrike" cap="none" dirty="0"/>
+                    </a:p>
+                  </a:txBody>
+                  <a:tcPr marL="182775" marR="182775" marT="182775" marB="182775" anchor="ctr">
+                    <a:lnL w="9525" cap="flat" cmpd="sng">
+                      <a:solidFill>
+                        <a:srgbClr val="FFFFFF">
+                          <a:alpha val="0"/>
+                        </a:srgbClr>
+                      </a:solidFill>
+                      <a:prstDash val="solid"/>
+                      <a:round/>
+                      <a:headEnd type="none" w="sm" len="sm"/>
+                      <a:tailEnd type="none" w="sm" len="sm"/>
+                    </a:lnL>
+                    <a:lnR w="9525" cap="flat" cmpd="sng">
+                      <a:solidFill>
+                        <a:srgbClr val="FFFFFF">
+                          <a:alpha val="0"/>
+                        </a:srgbClr>
+                      </a:solidFill>
+                      <a:prstDash val="solid"/>
+                      <a:round/>
+                      <a:headEnd type="none" w="sm" len="sm"/>
+                      <a:tailEnd type="none" w="sm" len="sm"/>
+                    </a:lnR>
+                    <a:lnT w="38100" cap="flat" cmpd="sng">
+                      <a:solidFill>
+                        <a:schemeClr val="lt1"/>
+                      </a:solidFill>
+                      <a:prstDash val="solid"/>
+                      <a:round/>
+                      <a:headEnd type="none" w="sm" len="sm"/>
+                      <a:tailEnd type="none" w="sm" len="sm"/>
+                    </a:lnT>
+                    <a:lnB w="38100" cap="flat" cmpd="sng">
+                      <a:solidFill>
+                        <a:schemeClr val="lt1"/>
+                      </a:solidFill>
+                      <a:prstDash val="solid"/>
+                      <a:round/>
+                      <a:headEnd type="none" w="sm" len="sm"/>
+                      <a:tailEnd type="none" w="sm" len="sm"/>
+                    </a:lnB>
+                    <a:solidFill>
+                      <a:srgbClr val="FF779A"/>
+                    </a:solidFill>
+                  </a:tcPr>
+                </a:tc>
+                <a:extLst>
+                  <a:ext uri="{0D108BD9-81ED-4DB2-BD59-A6C34878D82A}">
+                    <a16:rowId xmlns:a16="http://schemas.microsoft.com/office/drawing/2014/main" val="10002"/>
+                  </a:ext>
+                </a:extLst>
+              </a:tr>
+              <a:tr h="1447500">
+                <a:tc>
+                  <a:txBody>
+                    <a:bodyPr/>
+                    <a:lstStyle/>
+                    <a:p>
+                      <a:pPr marL="0" marR="0" lvl="0" indent="0" algn="ctr" rtl="0">
+                        <a:lnSpc>
+                          <a:spcPct val="139962"/>
+                        </a:lnSpc>
+                        <a:spcBef>
+                          <a:spcPts val="0"/>
+                        </a:spcBef>
+                        <a:spcAft>
+                          <a:spcPts val="0"/>
+                        </a:spcAft>
+                        <a:buNone/>
+                      </a:pPr>
+                      <a:r>
+                        <a:rPr lang="en-US" sz="2700" b="1" u="none" strike="noStrike" cap="none" dirty="0">
+                          <a:solidFill>
+                            <a:srgbClr val="FFFFFF"/>
+                          </a:solidFill>
+                          <a:latin typeface="Blinker"/>
+                          <a:ea typeface="Blinker"/>
+                          <a:cs typeface="Blinker"/>
+                          <a:sym typeface="Blinker"/>
+                        </a:rPr>
+                        <a:t>IA</a:t>
+                      </a:r>
+                      <a:endParaRPr lang="en-US" sz="1100" u="none" strike="noStrike" cap="none" dirty="0"/>
+                    </a:p>
+                  </a:txBody>
+                  <a:tcPr marL="182775" marR="182775" marT="182775" marB="182775" anchor="ctr">
+                    <a:lnL w="9525" cap="flat" cmpd="sng">
+                      <a:solidFill>
+                        <a:srgbClr val="FFFFFF">
+                          <a:alpha val="0"/>
+                        </a:srgbClr>
+                      </a:solidFill>
+                      <a:prstDash val="solid"/>
+                      <a:round/>
+                      <a:headEnd type="none" w="sm" len="sm"/>
+                      <a:tailEnd type="none" w="sm" len="sm"/>
+                    </a:lnL>
+                    <a:lnR w="9525" cap="flat" cmpd="sng">
+                      <a:solidFill>
+                        <a:srgbClr val="FFFFFF">
+                          <a:alpha val="0"/>
+                        </a:srgbClr>
+                      </a:solidFill>
+                      <a:prstDash val="solid"/>
+                      <a:round/>
+                      <a:headEnd type="none" w="sm" len="sm"/>
+                      <a:tailEnd type="none" w="sm" len="sm"/>
+                    </a:lnR>
+                    <a:lnT w="38100" cap="flat" cmpd="sng">
+                      <a:solidFill>
+                        <a:schemeClr val="lt1"/>
+                      </a:solidFill>
+                      <a:prstDash val="solid"/>
+                      <a:round/>
+                      <a:headEnd type="none" w="sm" len="sm"/>
+                      <a:tailEnd type="none" w="sm" len="sm"/>
+                    </a:lnT>
+                    <a:lnB w="38100" cap="flat" cmpd="sng">
+                      <a:solidFill>
+                        <a:schemeClr val="lt1"/>
+                      </a:solidFill>
+                      <a:prstDash val="solid"/>
+                      <a:round/>
+                      <a:headEnd type="none" w="sm" len="sm"/>
+                      <a:tailEnd type="none" w="sm" len="sm"/>
+                    </a:lnB>
+                    <a:solidFill>
+                      <a:srgbClr val="343F7F"/>
+                    </a:solidFill>
+                  </a:tcPr>
+                </a:tc>
+                <a:tc>
+                  <a:txBody>
+                    <a:bodyPr/>
+                    <a:lstStyle/>
+                    <a:p>
+                      <a:pPr marL="0" marR="0" lvl="0" indent="0" algn="ctr" rtl="0">
+                        <a:lnSpc>
+                          <a:spcPct val="140000"/>
+                        </a:lnSpc>
+                        <a:spcBef>
+                          <a:spcPts val="0"/>
+                        </a:spcBef>
+                        <a:spcAft>
+                          <a:spcPts val="0"/>
+                        </a:spcAft>
+                        <a:buNone/>
+                      </a:pPr>
+                      <a:r>
+                        <a:rPr lang="en-US" sz="3200" u="none" strike="noStrike" cap="none" dirty="0">
+                          <a:solidFill>
+                            <a:srgbClr val="FFFFFF"/>
+                          </a:solidFill>
+                          <a:latin typeface="League Spartan"/>
+                          <a:ea typeface="League Spartan"/>
+                          <a:cs typeface="League Spartan"/>
+                          <a:sym typeface="League Spartan"/>
+                        </a:rPr>
+                        <a:t>GITHUB COPILOT</a:t>
+                      </a:r>
+                      <a:r>
+                        <a:rPr lang="en-US" sz="1200" u="none" strike="noStrike" cap="none" dirty="0">
+                          <a:solidFill>
+                            <a:srgbClr val="FFFFFF"/>
+                          </a:solidFill>
+                          <a:latin typeface="League Spartan"/>
+                          <a:ea typeface="League Spartan"/>
+                          <a:cs typeface="League Spartan"/>
+                          <a:sym typeface="League Spartan"/>
+                        </a:rPr>
+                        <a:t>(DEV IA BACK)</a:t>
+                      </a:r>
+                      <a:endParaRPr sz="1100" u="none" strike="noStrike" cap="none" dirty="0"/>
+                    </a:p>
+                  </a:txBody>
+                  <a:tcPr marL="182775" marR="182775" marT="182775" marB="182775" anchor="ctr">
+                    <a:lnL w="9525" cap="flat" cmpd="sng">
+                      <a:solidFill>
+                        <a:srgbClr val="FFFFFF">
+                          <a:alpha val="0"/>
+                        </a:srgbClr>
+                      </a:solidFill>
+                      <a:prstDash val="solid"/>
+                      <a:round/>
+                      <a:headEnd type="none" w="sm" len="sm"/>
+                      <a:tailEnd type="none" w="sm" len="sm"/>
+                    </a:lnL>
+                    <a:lnR w="9525" cap="flat" cmpd="sng">
+                      <a:solidFill>
+                        <a:srgbClr val="FFFFFF">
+                          <a:alpha val="0"/>
+                        </a:srgbClr>
+                      </a:solidFill>
+                      <a:prstDash val="solid"/>
+                      <a:round/>
+                      <a:headEnd type="none" w="sm" len="sm"/>
+                      <a:tailEnd type="none" w="sm" len="sm"/>
+                    </a:lnR>
+                    <a:lnT w="38100" cap="flat" cmpd="sng">
+                      <a:solidFill>
+                        <a:schemeClr val="lt1"/>
+                      </a:solidFill>
+                      <a:prstDash val="solid"/>
+                      <a:round/>
+                      <a:headEnd type="none" w="sm" len="sm"/>
+                      <a:tailEnd type="none" w="sm" len="sm"/>
+                    </a:lnT>
+                    <a:lnB w="38100" cap="flat" cmpd="sng">
+                      <a:solidFill>
+                        <a:schemeClr val="lt1"/>
+                      </a:solidFill>
+                      <a:prstDash val="solid"/>
+                      <a:round/>
+                      <a:headEnd type="none" w="sm" len="sm"/>
+                      <a:tailEnd type="none" w="sm" len="sm"/>
+                    </a:lnB>
+                    <a:solidFill>
+                      <a:srgbClr val="343F7F"/>
+                    </a:solidFill>
+                  </a:tcPr>
+                </a:tc>
+                <a:tc>
+                  <a:txBody>
+                    <a:bodyPr/>
+                    <a:lstStyle/>
+                    <a:p>
+                      <a:pPr marL="0" marR="0" lvl="0" indent="0" algn="ctr" rtl="0">
+                        <a:lnSpc>
+                          <a:spcPct val="140000"/>
+                        </a:lnSpc>
+                        <a:spcBef>
+                          <a:spcPts val="0"/>
+                        </a:spcBef>
+                        <a:spcAft>
+                          <a:spcPts val="0"/>
+                        </a:spcAft>
+                        <a:buNone/>
+                      </a:pPr>
+                      <a:r>
+                        <a:rPr lang="en-US" sz="3545" u="none" strike="noStrike" cap="none" dirty="0">
+                          <a:solidFill>
+                            <a:srgbClr val="FFFFFF"/>
+                          </a:solidFill>
+                          <a:latin typeface="League Spartan"/>
+                          <a:ea typeface="League Spartan"/>
+                          <a:cs typeface="League Spartan"/>
+                          <a:sym typeface="League Spartan"/>
+                        </a:rPr>
+                        <a:t>WINDSURF</a:t>
+                      </a:r>
+                      <a:r>
+                        <a:rPr lang="en-US" sz="1200" u="none" strike="noStrike" cap="none" dirty="0">
+                          <a:solidFill>
+                            <a:srgbClr val="FFFFFF"/>
+                          </a:solidFill>
+                          <a:latin typeface="League Spartan"/>
+                          <a:ea typeface="League Spartan"/>
+                          <a:cs typeface="League Spartan"/>
+                          <a:sym typeface="League Spartan"/>
+                        </a:rPr>
+                        <a:t>(DEV IA FRONT)</a:t>
+                      </a:r>
+                      <a:endParaRPr sz="1200" u="none" strike="noStrike" cap="none" dirty="0"/>
+                    </a:p>
+                  </a:txBody>
+                  <a:tcPr marL="182775" marR="182775" marT="182775" marB="182775" anchor="ctr">
+                    <a:lnL w="9525" cap="flat" cmpd="sng">
+                      <a:solidFill>
+                        <a:srgbClr val="FFFFFF">
+                          <a:alpha val="0"/>
+                        </a:srgbClr>
+                      </a:solidFill>
+                      <a:prstDash val="solid"/>
+                      <a:round/>
+                      <a:headEnd type="none" w="sm" len="sm"/>
+                      <a:tailEnd type="none" w="sm" len="sm"/>
+                    </a:lnL>
+                    <a:lnR w="9525" cap="flat" cmpd="sng">
+                      <a:solidFill>
+                        <a:srgbClr val="FFFFFF">
+                          <a:alpha val="0"/>
+                        </a:srgbClr>
+                      </a:solidFill>
+                      <a:prstDash val="solid"/>
+                      <a:round/>
+                      <a:headEnd type="none" w="sm" len="sm"/>
+                      <a:tailEnd type="none" w="sm" len="sm"/>
+                    </a:lnR>
+                    <a:lnT w="38100" cap="flat" cmpd="sng">
+                      <a:solidFill>
+                        <a:schemeClr val="lt1"/>
+                      </a:solidFill>
+                      <a:prstDash val="solid"/>
+                      <a:round/>
+                      <a:headEnd type="none" w="sm" len="sm"/>
+                      <a:tailEnd type="none" w="sm" len="sm"/>
+                    </a:lnT>
+                    <a:lnB w="38100" cap="flat" cmpd="sng">
+                      <a:solidFill>
+                        <a:schemeClr val="lt1"/>
+                      </a:solidFill>
+                      <a:prstDash val="solid"/>
+                      <a:round/>
+                      <a:headEnd type="none" w="sm" len="sm"/>
+                      <a:tailEnd type="none" w="sm" len="sm"/>
+                    </a:lnB>
+                    <a:solidFill>
+                      <a:srgbClr val="343F7F"/>
+                    </a:solidFill>
+                  </a:tcPr>
+                </a:tc>
+                <a:tc>
+                  <a:txBody>
+                    <a:bodyPr/>
+                    <a:lstStyle/>
+                    <a:p>
+                      <a:pPr marL="0" marR="0" lvl="0" indent="0" algn="ctr" rtl="0">
+                        <a:lnSpc>
+                          <a:spcPct val="140000"/>
+                        </a:lnSpc>
+                        <a:spcBef>
+                          <a:spcPts val="0"/>
+                        </a:spcBef>
+                        <a:spcAft>
+                          <a:spcPts val="0"/>
+                        </a:spcAft>
+                        <a:buNone/>
+                      </a:pPr>
+                      <a:r>
+                        <a:rPr lang="en-US" sz="3545" u="none" strike="noStrike" cap="none" dirty="0">
+                          <a:solidFill>
+                            <a:srgbClr val="FFFFFF"/>
+                          </a:solidFill>
+                          <a:latin typeface="League Spartan"/>
+                          <a:ea typeface="League Spartan"/>
+                          <a:cs typeface="League Spartan"/>
+                          <a:sym typeface="League Spartan"/>
+                        </a:rPr>
+                        <a:t>CHATGPT</a:t>
+                      </a:r>
+                      <a:r>
+                        <a:rPr lang="en-US" sz="1200" u="none" strike="noStrike" cap="none" dirty="0">
+                          <a:solidFill>
+                            <a:srgbClr val="FFFFFF"/>
+                          </a:solidFill>
+                          <a:latin typeface="League Spartan"/>
+                          <a:ea typeface="League Spartan"/>
+                          <a:cs typeface="League Spartan"/>
+                          <a:sym typeface="League Spartan"/>
+                        </a:rPr>
+                        <a:t>(CHATBOT)</a:t>
+                      </a:r>
+                      <a:endParaRPr sz="1200" u="none" strike="noStrike" cap="none" dirty="0"/>
+                    </a:p>
+                  </a:txBody>
+                  <a:tcPr marL="182775" marR="182775" marT="182775" marB="182775" anchor="ctr">
+                    <a:lnL w="9525" cap="flat" cmpd="sng">
+                      <a:solidFill>
+                        <a:srgbClr val="FFFFFF">
+                          <a:alpha val="0"/>
+                        </a:srgbClr>
+                      </a:solidFill>
+                      <a:prstDash val="solid"/>
+                      <a:round/>
+                      <a:headEnd type="none" w="sm" len="sm"/>
+                      <a:tailEnd type="none" w="sm" len="sm"/>
+                    </a:lnL>
+                    <a:lnR w="9525" cap="flat" cmpd="sng">
+                      <a:solidFill>
+                        <a:srgbClr val="FFFFFF">
+                          <a:alpha val="0"/>
+                        </a:srgbClr>
+                      </a:solidFill>
+                      <a:prstDash val="solid"/>
+                      <a:round/>
+                      <a:headEnd type="none" w="sm" len="sm"/>
+                      <a:tailEnd type="none" w="sm" len="sm"/>
+                    </a:lnR>
+                    <a:lnT w="38100" cap="flat" cmpd="sng">
+                      <a:solidFill>
+                        <a:schemeClr val="lt1"/>
+                      </a:solidFill>
+                      <a:prstDash val="solid"/>
+                      <a:round/>
+                      <a:headEnd type="none" w="sm" len="sm"/>
+                      <a:tailEnd type="none" w="sm" len="sm"/>
+                    </a:lnT>
+                    <a:lnB w="38100" cap="flat" cmpd="sng">
+                      <a:solidFill>
+                        <a:schemeClr val="lt1"/>
+                      </a:solidFill>
+                      <a:prstDash val="solid"/>
+                      <a:round/>
+                      <a:headEnd type="none" w="sm" len="sm"/>
+                      <a:tailEnd type="none" w="sm" len="sm"/>
+                    </a:lnB>
+                    <a:solidFill>
+                      <a:srgbClr val="343F7F"/>
+                    </a:solidFill>
+                  </a:tcPr>
+                </a:tc>
+                <a:extLst>
+                  <a:ext uri="{0D108BD9-81ED-4DB2-BD59-A6C34878D82A}">
+                    <a16:rowId xmlns:a16="http://schemas.microsoft.com/office/drawing/2014/main" val="10003"/>
+                  </a:ext>
+                </a:extLst>
+              </a:tr>
+              <a:tr h="1525499">
+                <a:tc>
+                  <a:txBody>
+                    <a:bodyPr/>
+                    <a:lstStyle/>
+                    <a:p>
+                      <a:pPr marL="0" marR="0" lvl="0" indent="0" algn="ctr" rtl="0">
+                        <a:lnSpc>
+                          <a:spcPct val="139984"/>
+                        </a:lnSpc>
+                        <a:spcBef>
+                          <a:spcPts val="0"/>
+                        </a:spcBef>
+                        <a:spcAft>
+                          <a:spcPts val="0"/>
+                        </a:spcAft>
+                        <a:buNone/>
+                      </a:pPr>
+                      <a:r>
+                        <a:rPr lang="en-US" sz="3929" b="1" u="none" strike="noStrike" cap="none" dirty="0">
+                          <a:solidFill>
+                            <a:srgbClr val="FFFFFF"/>
+                          </a:solidFill>
+                          <a:latin typeface="Blinker"/>
+                          <a:ea typeface="Blinker"/>
+                          <a:cs typeface="Blinker"/>
+                          <a:sym typeface="Blinker"/>
+                        </a:rPr>
+                        <a:t>OUTROS</a:t>
+                      </a:r>
+                      <a:endParaRPr sz="1100" u="none" strike="noStrike" cap="none" dirty="0"/>
+                    </a:p>
+                  </a:txBody>
+                  <a:tcPr marL="182775" marR="182775" marT="182775" marB="182775" anchor="ctr">
+                    <a:lnL w="9525" cap="flat" cmpd="sng">
+                      <a:solidFill>
+                        <a:srgbClr val="FFFFFF">
+                          <a:alpha val="0"/>
+                        </a:srgbClr>
+                      </a:solidFill>
+                      <a:prstDash val="solid"/>
+                      <a:round/>
+                      <a:headEnd type="none" w="sm" len="sm"/>
+                      <a:tailEnd type="none" w="sm" len="sm"/>
+                    </a:lnL>
+                    <a:lnR w="9525" cap="flat" cmpd="sng">
+                      <a:solidFill>
+                        <a:srgbClr val="FFFFFF">
+                          <a:alpha val="0"/>
+                        </a:srgbClr>
+                      </a:solidFill>
+                      <a:prstDash val="solid"/>
+                      <a:round/>
+                      <a:headEnd type="none" w="sm" len="sm"/>
+                      <a:tailEnd type="none" w="sm" len="sm"/>
+                    </a:lnR>
+                    <a:lnT w="38100" cap="flat" cmpd="sng">
+                      <a:solidFill>
+                        <a:schemeClr val="lt1"/>
+                      </a:solidFill>
+                      <a:prstDash val="solid"/>
+                      <a:round/>
+                      <a:headEnd type="none" w="sm" len="sm"/>
+                      <a:tailEnd type="none" w="sm" len="sm"/>
+                    </a:lnT>
+                    <a:lnB w="9525" cap="flat" cmpd="sng">
+                      <a:solidFill>
+                        <a:srgbClr val="FFFFFF">
+                          <a:alpha val="0"/>
+                        </a:srgbClr>
+                      </a:solidFill>
+                      <a:prstDash val="solid"/>
+                      <a:round/>
+                      <a:headEnd type="none" w="sm" len="sm"/>
+                      <a:tailEnd type="none" w="sm" len="sm"/>
+                    </a:lnB>
+                    <a:solidFill>
+                      <a:srgbClr val="CE8FFF"/>
+                    </a:solidFill>
+                  </a:tcPr>
+                </a:tc>
+                <a:tc>
+                  <a:txBody>
+                    <a:bodyPr/>
+                    <a:lstStyle/>
+                    <a:p>
+                      <a:pPr marL="0" marR="0" lvl="0" indent="0" algn="ctr" rtl="0">
+                        <a:lnSpc>
+                          <a:spcPct val="140000"/>
+                        </a:lnSpc>
+                        <a:spcBef>
+                          <a:spcPts val="0"/>
+                        </a:spcBef>
+                        <a:spcAft>
+                          <a:spcPts val="0"/>
+                        </a:spcAft>
+                        <a:buNone/>
+                      </a:pPr>
+                      <a:r>
+                        <a:rPr lang="en-US" sz="3545" u="none" strike="noStrike" cap="none" dirty="0">
+                          <a:solidFill>
+                            <a:schemeClr val="bg1"/>
+                          </a:solidFill>
+                          <a:latin typeface="League Spartan"/>
+                          <a:ea typeface="League Spartan"/>
+                          <a:cs typeface="League Spartan"/>
+                          <a:sym typeface="League Spartan"/>
+                        </a:rPr>
+                        <a:t>SQL SERVER</a:t>
+                      </a:r>
+                      <a:endParaRPr sz="1100" u="none" strike="noStrike" cap="none" dirty="0">
+                        <a:solidFill>
+                          <a:schemeClr val="bg1"/>
+                        </a:solidFill>
+                      </a:endParaRPr>
+                    </a:p>
+                  </a:txBody>
+                  <a:tcPr marL="182775" marR="182775" marT="182775" marB="182775" anchor="ctr">
+                    <a:lnL w="9525" cap="flat" cmpd="sng">
+                      <a:solidFill>
+                        <a:srgbClr val="FFFFFF">
+                          <a:alpha val="0"/>
+                        </a:srgbClr>
+                      </a:solidFill>
+                      <a:prstDash val="solid"/>
+                      <a:round/>
+                      <a:headEnd type="none" w="sm" len="sm"/>
+                      <a:tailEnd type="none" w="sm" len="sm"/>
+                    </a:lnL>
+                    <a:lnR w="9525" cap="flat" cmpd="sng">
+                      <a:solidFill>
+                        <a:srgbClr val="FFFFFF">
+                          <a:alpha val="0"/>
+                        </a:srgbClr>
+                      </a:solidFill>
+                      <a:prstDash val="solid"/>
+                      <a:round/>
+                      <a:headEnd type="none" w="sm" len="sm"/>
+                      <a:tailEnd type="none" w="sm" len="sm"/>
+                    </a:lnR>
+                    <a:lnT w="38100" cap="flat" cmpd="sng">
+                      <a:solidFill>
+                        <a:schemeClr val="lt1"/>
+                      </a:solidFill>
+                      <a:prstDash val="solid"/>
+                      <a:round/>
+                      <a:headEnd type="none" w="sm" len="sm"/>
+                      <a:tailEnd type="none" w="sm" len="sm"/>
+                    </a:lnT>
+                    <a:lnB w="9525" cap="flat" cmpd="sng">
+                      <a:solidFill>
+                        <a:srgbClr val="FFFFFF">
+                          <a:alpha val="0"/>
+                        </a:srgbClr>
+                      </a:solidFill>
+                      <a:prstDash val="solid"/>
+                      <a:round/>
+                      <a:headEnd type="none" w="sm" len="sm"/>
+                      <a:tailEnd type="none" w="sm" len="sm"/>
+                    </a:lnB>
+                    <a:solidFill>
+                      <a:srgbClr val="CE8FFF"/>
+                    </a:solidFill>
+                  </a:tcPr>
+                </a:tc>
+                <a:tc>
+                  <a:txBody>
+                    <a:bodyPr/>
+                    <a:lstStyle/>
+                    <a:p>
+                      <a:pPr marL="0" marR="0" lvl="0" indent="0" algn="ctr" rtl="0">
+                        <a:lnSpc>
+                          <a:spcPct val="140000"/>
+                        </a:lnSpc>
+                        <a:spcBef>
+                          <a:spcPts val="0"/>
+                        </a:spcBef>
+                        <a:spcAft>
+                          <a:spcPts val="0"/>
+                        </a:spcAft>
+                        <a:buNone/>
+                      </a:pPr>
+                      <a:r>
+                        <a:rPr lang="en-US" sz="3545" u="none" strike="noStrike" cap="none" dirty="0">
+                          <a:solidFill>
+                            <a:schemeClr val="bg1"/>
+                          </a:solidFill>
+                          <a:latin typeface="League Spartan"/>
+                          <a:ea typeface="League Spartan"/>
+                          <a:cs typeface="League Spartan"/>
+                          <a:sym typeface="League Spartan"/>
+                        </a:rPr>
+                        <a:t>CYPRESS</a:t>
+                      </a:r>
+                      <a:endParaRPr sz="1100" u="none" strike="noStrike" cap="none" dirty="0">
+                        <a:solidFill>
+                          <a:schemeClr val="bg1"/>
+                        </a:solidFill>
+                      </a:endParaRPr>
+                    </a:p>
+                  </a:txBody>
+                  <a:tcPr marL="182775" marR="182775" marT="182775" marB="182775" anchor="ctr">
+                    <a:lnL w="9525" cap="flat" cmpd="sng">
+                      <a:solidFill>
+                        <a:srgbClr val="FFFFFF">
+                          <a:alpha val="0"/>
+                        </a:srgbClr>
+                      </a:solidFill>
+                      <a:prstDash val="solid"/>
+                      <a:round/>
+                      <a:headEnd type="none" w="sm" len="sm"/>
+                      <a:tailEnd type="none" w="sm" len="sm"/>
+                    </a:lnL>
+                    <a:lnR w="9525" cap="flat" cmpd="sng">
+                      <a:solidFill>
+                        <a:srgbClr val="FFFFFF">
+                          <a:alpha val="0"/>
+                        </a:srgbClr>
+                      </a:solidFill>
+                      <a:prstDash val="solid"/>
+                      <a:round/>
+                      <a:headEnd type="none" w="sm" len="sm"/>
+                      <a:tailEnd type="none" w="sm" len="sm"/>
+                    </a:lnR>
+                    <a:lnT w="38100" cap="flat" cmpd="sng">
+                      <a:solidFill>
+                        <a:schemeClr val="lt1"/>
+                      </a:solidFill>
+                      <a:prstDash val="solid"/>
+                      <a:round/>
+                      <a:headEnd type="none" w="sm" len="sm"/>
+                      <a:tailEnd type="none" w="sm" len="sm"/>
+                    </a:lnT>
+                    <a:lnB w="9525" cap="flat" cmpd="sng">
+                      <a:solidFill>
+                        <a:srgbClr val="FFFFFF">
+                          <a:alpha val="0"/>
+                        </a:srgbClr>
+                      </a:solidFill>
+                      <a:prstDash val="solid"/>
+                      <a:round/>
+                      <a:headEnd type="none" w="sm" len="sm"/>
+                      <a:tailEnd type="none" w="sm" len="sm"/>
+                    </a:lnB>
+                    <a:solidFill>
+                      <a:srgbClr val="CE8FFF"/>
+                    </a:solidFill>
+                  </a:tcPr>
+                </a:tc>
+                <a:tc>
+                  <a:txBody>
+                    <a:bodyPr/>
+                    <a:lstStyle/>
+                    <a:p>
+                      <a:pPr marL="0" marR="0" lvl="0" indent="0" algn="ctr" rtl="0">
+                        <a:lnSpc>
+                          <a:spcPct val="140000"/>
+                        </a:lnSpc>
+                        <a:spcBef>
+                          <a:spcPts val="0"/>
+                        </a:spcBef>
+                        <a:spcAft>
+                          <a:spcPts val="0"/>
+                        </a:spcAft>
+                        <a:buNone/>
+                      </a:pPr>
+                      <a:endParaRPr sz="1100" u="none" strike="noStrike" cap="none" dirty="0"/>
+                    </a:p>
+                  </a:txBody>
+                  <a:tcPr marL="182775" marR="182775" marT="182775" marB="182775" anchor="ctr">
+                    <a:lnL w="9525" cap="flat" cmpd="sng">
+                      <a:solidFill>
+                        <a:srgbClr val="FFFFFF">
+                          <a:alpha val="0"/>
+                        </a:srgbClr>
+                      </a:solidFill>
+                      <a:prstDash val="solid"/>
+                      <a:round/>
+                      <a:headEnd type="none" w="sm" len="sm"/>
+                      <a:tailEnd type="none" w="sm" len="sm"/>
+                    </a:lnL>
+                    <a:lnR w="9525" cap="flat" cmpd="sng">
+                      <a:solidFill>
+                        <a:srgbClr val="FFFFFF">
+                          <a:alpha val="0"/>
+                        </a:srgbClr>
+                      </a:solidFill>
+                      <a:prstDash val="solid"/>
+                      <a:round/>
+                      <a:headEnd type="none" w="sm" len="sm"/>
+                      <a:tailEnd type="none" w="sm" len="sm"/>
+                    </a:lnR>
+                    <a:lnT w="38100" cap="flat" cmpd="sng">
+                      <a:solidFill>
+                        <a:schemeClr val="lt1"/>
+                      </a:solidFill>
+                      <a:prstDash val="solid"/>
+                      <a:round/>
+                      <a:headEnd type="none" w="sm" len="sm"/>
+                      <a:tailEnd type="none" w="sm" len="sm"/>
+                    </a:lnT>
+                    <a:lnB w="9525" cap="flat" cmpd="sng">
+                      <a:solidFill>
+                        <a:srgbClr val="FFFFFF">
+                          <a:alpha val="0"/>
+                        </a:srgbClr>
+                      </a:solidFill>
+                      <a:prstDash val="solid"/>
+                      <a:round/>
+                      <a:headEnd type="none" w="sm" len="sm"/>
+                      <a:tailEnd type="none" w="sm" len="sm"/>
+                    </a:lnB>
+                    <a:solidFill>
+                      <a:srgbClr val="CE8FFF"/>
+                    </a:solidFill>
+                  </a:tcPr>
+                </a:tc>
+                <a:extLst>
+                  <a:ext uri="{0D108BD9-81ED-4DB2-BD59-A6C34878D82A}">
+                    <a16:rowId xmlns:a16="http://schemas.microsoft.com/office/drawing/2014/main" val="10004"/>
+                  </a:ext>
+                </a:extLst>
+              </a:tr>
+            </a:tbl>
+          </a:graphicData>
+        </a:graphic>
+      </p:graphicFrame>
       <p:sp>
         <p:nvSpPr>
-          <p:cNvPr id="100" name="Google Shape;100;p14">
+          <p:cNvPr id="486" name="Google Shape;486;p27">
             <a:extLst>
               <a:ext uri="{FF2B5EF4-FFF2-40B4-BE49-F238E27FC236}">
-                <a16:creationId xmlns:a16="http://schemas.microsoft.com/office/drawing/2014/main" id="{739D01CF-F0A8-793D-7C47-EAA4BDBD08F6}"/>
+                <a16:creationId xmlns:a16="http://schemas.microsoft.com/office/drawing/2014/main" id="{7CB210EB-9F2B-B604-8EF1-6B0635434D35}"/>
               </a:ext>
             </a:extLst>
           </p:cNvPr>
@@ -13539,8 +13372,8 @@
         </p:nvSpPr>
         <p:spPr>
           <a:xfrm>
-            <a:off x="1697662" y="1096299"/>
-            <a:ext cx="14892600" cy="1702902"/>
+            <a:off x="3842105" y="843462"/>
+            <a:ext cx="10603800" cy="1553502"/>
           </a:xfrm>
           <a:prstGeom prst="rect">
             <a:avLst/>
@@ -13558,7 +13391,7 @@
           <a:p>
             <a:pPr marL="0" marR="0" lvl="0" indent="0" algn="ctr" rtl="0">
               <a:lnSpc>
-                <a:spcPct val="110000"/>
+                <a:spcPct val="110019"/>
               </a:lnSpc>
               <a:spcBef>
                 <a:spcPts val="0"/>
@@ -13569,37 +13402,50 @@
               <a:buNone/>
             </a:pPr>
             <a:r>
-              <a:rPr lang="en-US" sz="10060" b="1" i="0" u="none" strike="noStrike" cap="none" dirty="0">
+              <a:rPr lang="en-US" sz="9177" i="0" u="none" strike="noStrike" cap="none" dirty="0">
                 <a:solidFill>
-                  <a:srgbClr val="BCFFB9"/>
+                  <a:srgbClr val="FDED8F"/>
                 </a:solidFill>
-                <a:latin typeface="League Spartan"/>
-                <a:ea typeface="League Spartan"/>
-                <a:cs typeface="League Spartan"/>
-                <a:sym typeface="League Spartan"/>
+                <a:latin typeface="League Spartan ExtraBold"/>
+                <a:ea typeface="League Spartan ExtraBold"/>
+                <a:cs typeface="League Spartan ExtraBold"/>
+                <a:sym typeface="League Spartan ExtraBold"/>
               </a:rPr>
-              <a:t>TESTES</a:t>
+              <a:t>TECNOLOGIAS</a:t>
             </a:r>
-            <a:endParaRPr sz="3700" dirty="0"/>
+            <a:endParaRPr sz="3400" dirty="0">
+              <a:latin typeface="League Spartan ExtraBold"/>
+              <a:ea typeface="League Spartan ExtraBold"/>
+              <a:cs typeface="League Spartan ExtraBold"/>
+              <a:sym typeface="League Spartan ExtraBold"/>
+            </a:endParaRPr>
           </a:p>
         </p:txBody>
       </p:sp>
-      <p:sp>
-        <p:nvSpPr>
-          <p:cNvPr id="105" name="Google Shape;105;p14">
+      <p:pic>
+        <p:nvPicPr>
+          <p:cNvPr id="487" name="Google Shape;487;p27">
             <a:extLst>
               <a:ext uri="{FF2B5EF4-FFF2-40B4-BE49-F238E27FC236}">
-                <a16:creationId xmlns:a16="http://schemas.microsoft.com/office/drawing/2014/main" id="{23DC761A-8948-27BD-D547-D4B5EF60654E}"/>
+                <a16:creationId xmlns:a16="http://schemas.microsoft.com/office/drawing/2014/main" id="{D30F0EA1-3A3D-0348-2144-B0EDD20C6C5C}"/>
               </a:ext>
             </a:extLst>
           </p:cNvPr>
-          <p:cNvSpPr txBox="1"/>
+          <p:cNvPicPr preferRelativeResize="0"/>
           <p:nvPr/>
-        </p:nvSpPr>
+        </p:nvPicPr>
+        <p:blipFill>
+          <a:blip r:embed="rId3">
+            <a:alphaModFix/>
+          </a:blip>
+          <a:stretch>
+            <a:fillRect/>
+          </a:stretch>
+        </p:blipFill>
         <p:spPr>
           <a:xfrm>
-            <a:off x="5944084" y="6795865"/>
-            <a:ext cx="6399900" cy="639983"/>
+            <a:off x="14878525" y="-5831100"/>
+            <a:ext cx="8693699" cy="8693699"/>
           </a:xfrm>
           <a:prstGeom prst="rect">
             <a:avLst/>
@@ -13609,73 +13455,45 @@
             <a:noFill/>
           </a:ln>
         </p:spPr>
-        <p:txBody>
-          <a:bodyPr spcFirstLastPara="1" wrap="square" lIns="0" tIns="0" rIns="0" bIns="0" anchor="t" anchorCtr="0">
-            <a:spAutoFit/>
-          </a:bodyPr>
-          <a:lstStyle/>
-          <a:p>
-            <a:pPr marL="0" marR="0" lvl="0" indent="0" algn="ctr" rtl="0">
-              <a:lnSpc>
-                <a:spcPct val="130009"/>
-              </a:lnSpc>
-              <a:spcBef>
-                <a:spcPts val="0"/>
-              </a:spcBef>
-              <a:spcAft>
-                <a:spcPts val="0"/>
-              </a:spcAft>
-              <a:buNone/>
-            </a:pPr>
-            <a:r>
-              <a:rPr lang="en-US" sz="3199" b="1" i="0" u="none" strike="noStrike" cap="none" dirty="0">
-                <a:solidFill>
-                  <a:srgbClr val="FF779A"/>
-                </a:solidFill>
-                <a:latin typeface="Blinker"/>
-                <a:ea typeface="Blinker"/>
-                <a:cs typeface="Blinker"/>
-                <a:sym typeface="Blinker"/>
-              </a:rPr>
-              <a:t>CYPRESS</a:t>
-            </a:r>
-          </a:p>
-        </p:txBody>
-      </p:sp>
+      </p:pic>
       <p:pic>
         <p:nvPicPr>
-          <p:cNvPr id="3" name="Imagem 2">
+          <p:cNvPr id="488" name="Google Shape;488;p27">
             <a:extLst>
               <a:ext uri="{FF2B5EF4-FFF2-40B4-BE49-F238E27FC236}">
-                <a16:creationId xmlns:a16="http://schemas.microsoft.com/office/drawing/2014/main" id="{9F973035-98A7-F96A-B1E1-FFADE663C62C}"/>
+                <a16:creationId xmlns:a16="http://schemas.microsoft.com/office/drawing/2014/main" id="{3E04E081-2F95-8D50-2028-362DFD5F4DF8}"/>
               </a:ext>
             </a:extLst>
           </p:cNvPr>
-          <p:cNvPicPr>
-            <a:picLocks noChangeAspect="1"/>
-          </p:cNvPicPr>
+          <p:cNvPicPr preferRelativeResize="0"/>
           <p:nvPr/>
         </p:nvPicPr>
         <p:blipFill>
-          <a:blip r:embed="rId4"/>
+          <a:blip r:embed="rId3">
+            <a:alphaModFix/>
+          </a:blip>
           <a:stretch>
             <a:fillRect/>
           </a:stretch>
         </p:blipFill>
         <p:spPr>
           <a:xfrm>
-            <a:off x="7967323" y="3844194"/>
-            <a:ext cx="2258570" cy="2258570"/>
+            <a:off x="-5322496" y="7978503"/>
+            <a:ext cx="8693699" cy="8693699"/>
           </a:xfrm>
           <a:prstGeom prst="rect">
             <a:avLst/>
           </a:prstGeom>
+          <a:noFill/>
+          <a:ln>
+            <a:noFill/>
+          </a:ln>
         </p:spPr>
       </p:pic>
     </p:spTree>
     <p:extLst>
       <p:ext uri="{BB962C8B-B14F-4D97-AF65-F5344CB8AC3E}">
-        <p14:creationId xmlns:p14="http://schemas.microsoft.com/office/powerpoint/2010/main" val="1756598803"/>
+        <p14:creationId xmlns:p14="http://schemas.microsoft.com/office/powerpoint/2010/main" val="2889343071"/>
       </p:ext>
     </p:extLst>
   </p:cSld>

</xml_diff>